<commit_message>
New sourced data, spacing/perf pass, location statement, article dates
- Data: NCAA 2024-25 (record 242,341 women athletes; 5,126 women head
  coaches), NFHS 2024-25 (record 3.54M girls), Opendorse NIL at 3 ($1.67B
  market; women's share by deal type). Home "By the numbers", NIL toolkit
  "NIL by the numbers", asterisk citations; 6th coaching stat (Tucker 47.5%)
- Decks: new "By the numbers" slide 4 (public + internal); asterisk fix
- Layout audit: all pages x 7 widths, no overlap/overflow; placeholder
  badges no longer cover text; why-we-exist grid fills evenly
- Performance: hero video starts after page load/idle; preload hero poster
  per breakpoint; unused font weight dropped; cache headers for media
- Location: Charlotte stated once as HQ serving Mid-Atlantic, NE, SE, MW,
  West Coast; repeated mentions removed; footer "Serving clients nationwide"
- Articles re-dated monthly: Aug 12, Sep 9, Oct 7 2026

Co-Authored-By: Claude Opus 5.5 <noreply@anthropic.com>
</commit_message>
<xml_diff>
--- a/_strategy/Dexter_Sports_Investor_Deck_INTERNAL.pptx
+++ b/_strategy/Dexter_Sports_Investor_Deck_INTERNAL.pptx
@@ -5,24 +5,25 @@
     <p:sldMasterId id="2147483648" r:id="rId1"/>
   </p:sldMasterIdLst>
   <p:notesMasterIdLst>
-    <p:notesMasterId r:id="rId17"/>
+    <p:notesMasterId r:id="rId18"/>
   </p:notesMasterIdLst>
   <p:sldIdLst>
     <p:sldId id="256" r:id="rId2"/>
     <p:sldId id="257" r:id="rId3"/>
     <p:sldId id="258" r:id="rId4"/>
-    <p:sldId id="259" r:id="rId5"/>
-    <p:sldId id="260" r:id="rId6"/>
-    <p:sldId id="261" r:id="rId7"/>
-    <p:sldId id="262" r:id="rId8"/>
-    <p:sldId id="263" r:id="rId9"/>
-    <p:sldId id="264" r:id="rId10"/>
-    <p:sldId id="265" r:id="rId11"/>
-    <p:sldId id="266" r:id="rId12"/>
-    <p:sldId id="267" r:id="rId13"/>
-    <p:sldId id="268" r:id="rId14"/>
-    <p:sldId id="269" r:id="rId15"/>
-    <p:sldId id="270" r:id="rId16"/>
+    <p:sldId id="271" r:id="rId5"/>
+    <p:sldId id="259" r:id="rId6"/>
+    <p:sldId id="260" r:id="rId7"/>
+    <p:sldId id="261" r:id="rId8"/>
+    <p:sldId id="262" r:id="rId9"/>
+    <p:sldId id="263" r:id="rId10"/>
+    <p:sldId id="264" r:id="rId11"/>
+    <p:sldId id="265" r:id="rId12"/>
+    <p:sldId id="266" r:id="rId13"/>
+    <p:sldId id="267" r:id="rId14"/>
+    <p:sldId id="268" r:id="rId15"/>
+    <p:sldId id="269" r:id="rId16"/>
+    <p:sldId id="270" r:id="rId17"/>
   </p:sldIdLst>
   <p:sldSz cx="12192000" cy="6858000"/>
   <p:notesSz cx="6858000" cy="12192000"/>
@@ -1186,6 +1187,90 @@
             <a:fld id="{F7021451-1387-4CA6-816F-3879F97B5CBC}" type="slidenum">
               <a:rPr lang="en-US"/>
               <a:t>15</a:t>
+            </a:fld>
+            <a:endParaRPr lang="en-US"/>
+          </a:p>
+        </p:txBody>
+      </p:sp>
+    </p:spTree>
+    <p:extLst>
+      <p:ext uri="{BB962C8B-B14F-4D97-AF65-F5344CB8AC3E}">
+        <p14:creationId xmlns:p14="http://schemas.microsoft.com/office/powerpoint/2010/main" val="1024086991"/>
+      </p:ext>
+    </p:extLst>
+  </p:cSld>
+  <p:clrMapOvr>
+    <a:masterClrMapping/>
+  </p:clrMapOvr>
+</p:notes>
+</file>
+
+<file path=ppt/notesSlides/notesSlide16.xml><?xml version="1.0" encoding="utf-8"?>
+<p:notes xmlns:a="http://schemas.openxmlformats.org/drawingml/2006/main" xmlns:r="http://schemas.openxmlformats.org/officeDocument/2006/relationships" xmlns:p="http://schemas.openxmlformats.org/presentationml/2006/main">
+  <p:cSld>
+    <p:spTree>
+      <p:nvGrpSpPr>
+        <p:cNvPr id="1" name=""/>
+        <p:cNvGrpSpPr/>
+        <p:nvPr/>
+      </p:nvGrpSpPr>
+      <p:grpSpPr>
+        <a:xfrm>
+          <a:off x="0" y="0"/>
+          <a:ext cx="0" cy="0"/>
+          <a:chOff x="0" y="0"/>
+          <a:chExt cx="0" cy="0"/>
+        </a:xfrm>
+      </p:grpSpPr>
+      <p:sp>
+        <p:nvSpPr>
+          <p:cNvPr id="2" name="Slide Image Placeholder 1"/>
+          <p:cNvSpPr>
+            <a:spLocks noGrp="1" noRot="1" noChangeAspect="1"/>
+          </p:cNvSpPr>
+          <p:nvPr>
+            <p:ph type="sldImg"/>
+          </p:nvPr>
+        </p:nvSpPr>
+        <p:spPr/>
+      </p:sp>
+      <p:sp>
+        <p:nvSpPr>
+          <p:cNvPr id="3" name="Notes Placeholder 2"/>
+          <p:cNvSpPr>
+            <a:spLocks noGrp="1"/>
+          </p:cNvSpPr>
+          <p:nvPr>
+            <p:ph type="body" idx="1"/>
+          </p:nvPr>
+        </p:nvSpPr>
+        <p:spPr/>
+        <p:txBody>
+          <a:bodyPr/>
+          <a:lstStyle/>
+          <a:p>
+            <a:endParaRPr lang="en-US" dirty="0"/>
+          </a:p>
+        </p:txBody>
+      </p:sp>
+      <p:sp>
+        <p:nvSpPr>
+          <p:cNvPr id="4" name="Slide Number Placeholder 3"/>
+          <p:cNvSpPr>
+            <a:spLocks noGrp="1"/>
+          </p:cNvSpPr>
+          <p:nvPr>
+            <p:ph type="sldNum" sz="quarter" idx="10"/>
+          </p:nvPr>
+        </p:nvSpPr>
+        <p:spPr/>
+        <p:txBody>
+          <a:bodyPr/>
+          <a:lstStyle/>
+          <a:p>
+            <a:fld id="{F7021451-1387-4CA6-816F-3879F97B5CBC}" type="slidenum">
+              <a:rPr lang="en-US"/>
+              <a:t>16</a:t>
             </a:fld>
             <a:endParaRPr lang="en-US"/>
           </a:p>
@@ -2659,6 +2744,911 @@
 
 <file path=ppt/slides/slide10.xml><?xml version="1.0" encoding="utf-8"?>
 <p:sld xmlns:a="http://schemas.openxmlformats.org/drawingml/2006/main" xmlns:r="http://schemas.openxmlformats.org/officeDocument/2006/relationships" xmlns:p="http://schemas.openxmlformats.org/presentationml/2006/main">
+  <p:cSld name="Slide 9">
+    <p:bg>
+      <p:bgPr>
+        <a:solidFill>
+          <a:srgbClr val="FFFFFF"/>
+        </a:solidFill>
+        <a:effectLst/>
+      </p:bgPr>
+    </p:bg>
+    <p:spTree>
+      <p:nvGrpSpPr>
+        <p:cNvPr id="1" name=""/>
+        <p:cNvGrpSpPr/>
+        <p:nvPr/>
+      </p:nvGrpSpPr>
+      <p:grpSpPr>
+        <a:xfrm>
+          <a:off x="0" y="0"/>
+          <a:ext cx="0" cy="0"/>
+          <a:chOff x="0" y="0"/>
+          <a:chExt cx="0" cy="0"/>
+        </a:xfrm>
+      </p:grpSpPr>
+      <p:sp>
+        <p:nvSpPr>
+          <p:cNvPr id="2" name="Text 0"/>
+          <p:cNvSpPr/>
+          <p:nvPr/>
+        </p:nvSpPr>
+        <p:spPr>
+          <a:xfrm>
+            <a:off x="685800" y="548640"/>
+            <a:ext cx="9144000" cy="274320"/>
+          </a:xfrm>
+          <a:prstGeom prst="rect">
+            <a:avLst/>
+          </a:prstGeom>
+          <a:noFill/>
+          <a:ln/>
+        </p:spPr>
+        <p:txBody>
+          <a:bodyPr wrap="square" rtlCol="0" anchor="ctr"/>
+          <a:lstStyle/>
+          <a:p>
+            <a:pPr marL="0" indent="0">
+              <a:buNone/>
+            </a:pPr>
+            <a:r>
+              <a:rPr lang="en-US" sz="800" dirty="0">
+                <a:solidFill>
+                  <a:srgbClr val="2563EB"/>
+                </a:solidFill>
+                <a:latin typeface="Arial" pitchFamily="34" charset="0"/>
+                <a:ea typeface="Arial" pitchFamily="34" charset="-122"/>
+                <a:cs typeface="Arial" pitchFamily="34" charset="-120"/>
+              </a:rPr>
+              <a:t>● </a:t>
+            </a:r>
+            <a:r>
+              <a:rPr lang="en-US" sz="1100" b="1" kern="0" spc="300" dirty="0">
+                <a:solidFill>
+                  <a:srgbClr val="2563EB"/>
+                </a:solidFill>
+                <a:latin typeface="Arial" pitchFamily="34" charset="0"/>
+                <a:ea typeface="Arial" pitchFamily="34" charset="-122"/>
+                <a:cs typeface="Arial" pitchFamily="34" charset="-120"/>
+              </a:rPr>
+              <a:t>WHAT WE DO</a:t>
+            </a:r>
+            <a:endParaRPr lang="en-US" sz="1100" dirty="0"/>
+          </a:p>
+        </p:txBody>
+      </p:sp>
+      <p:sp>
+        <p:nvSpPr>
+          <p:cNvPr id="3" name="Text 1"/>
+          <p:cNvSpPr/>
+          <p:nvPr/>
+        </p:nvSpPr>
+        <p:spPr>
+          <a:xfrm>
+            <a:off x="685800" y="868680"/>
+            <a:ext cx="10789920" cy="640080"/>
+          </a:xfrm>
+          <a:prstGeom prst="rect">
+            <a:avLst/>
+          </a:prstGeom>
+          <a:noFill/>
+          <a:ln/>
+        </p:spPr>
+        <p:txBody>
+          <a:bodyPr wrap="square" rtlCol="0" anchor="ctr"/>
+          <a:lstStyle/>
+          <a:p>
+            <a:pPr marL="0" indent="0">
+              <a:buNone/>
+            </a:pPr>
+            <a:r>
+              <a:rPr lang="en-US" sz="2900" b="1" dirty="0">
+                <a:solidFill>
+                  <a:srgbClr val="141A24"/>
+                </a:solidFill>
+                <a:latin typeface="Arial" pitchFamily="34" charset="0"/>
+                <a:ea typeface="Arial" pitchFamily="34" charset="-122"/>
+                <a:cs typeface="Arial" pitchFamily="34" charset="-120"/>
+              </a:rPr>
+              <a:t>Two specialties. </a:t>
+            </a:r>
+            <a:r>
+              <a:rPr lang="en-US" sz="2900" i="1" dirty="0">
+                <a:solidFill>
+                  <a:srgbClr val="2563EB"/>
+                </a:solidFill>
+                <a:latin typeface="Georgia" pitchFamily="34" charset="0"/>
+                <a:ea typeface="Georgia" pitchFamily="34" charset="-122"/>
+                <a:cs typeface="Georgia" pitchFamily="34" charset="-120"/>
+              </a:rPr>
+              <a:t>One advocate.</a:t>
+            </a:r>
+            <a:endParaRPr lang="en-US" sz="2900" dirty="0"/>
+          </a:p>
+        </p:txBody>
+      </p:sp>
+      <p:sp>
+        <p:nvSpPr>
+          <p:cNvPr id="4" name="Text 2"/>
+          <p:cNvSpPr/>
+          <p:nvPr/>
+        </p:nvSpPr>
+        <p:spPr>
+          <a:xfrm>
+            <a:off x="685800" y="1481328"/>
+            <a:ext cx="10789920" cy="365760"/>
+          </a:xfrm>
+          <a:prstGeom prst="rect">
+            <a:avLst/>
+          </a:prstGeom>
+          <a:noFill/>
+          <a:ln/>
+        </p:spPr>
+        <p:txBody>
+          <a:bodyPr wrap="square" rtlCol="0" anchor="ctr"/>
+          <a:lstStyle/>
+          <a:p>
+            <a:pPr marL="0" indent="0">
+              <a:buNone/>
+            </a:pPr>
+            <a:r>
+              <a:rPr lang="en-US" sz="1350" i="1" dirty="0">
+                <a:solidFill>
+                  <a:srgbClr val="6B7280"/>
+                </a:solidFill>
+                <a:latin typeface="Arial" pitchFamily="34" charset="0"/>
+                <a:ea typeface="Arial" pitchFamily="34" charset="-122"/>
+                <a:cs typeface="Arial" pitchFamily="34" charset="-120"/>
+              </a:rPr>
+              <a:t>From the next contract to the first NIL offer — coach representation and NIL guidance are the co-equal core.</a:t>
+            </a:r>
+            <a:endParaRPr lang="en-US" sz="1350" dirty="0"/>
+          </a:p>
+        </p:txBody>
+      </p:sp>
+      <p:sp>
+        <p:nvSpPr>
+          <p:cNvPr id="5" name="Shape 3"/>
+          <p:cNvSpPr/>
+          <p:nvPr/>
+        </p:nvSpPr>
+        <p:spPr>
+          <a:xfrm>
+            <a:off x="685800" y="2103120"/>
+            <a:ext cx="5230368" cy="2331720"/>
+          </a:xfrm>
+          <a:prstGeom prst="roundRect">
+            <a:avLst>
+              <a:gd name="adj" fmla="val 4706"/>
+            </a:avLst>
+          </a:prstGeom>
+          <a:solidFill>
+            <a:srgbClr val="0B1220"/>
+          </a:solidFill>
+          <a:ln/>
+        </p:spPr>
+      </p:sp>
+      <p:sp>
+        <p:nvSpPr>
+          <p:cNvPr id="6" name="Shape 4"/>
+          <p:cNvSpPr/>
+          <p:nvPr/>
+        </p:nvSpPr>
+        <p:spPr>
+          <a:xfrm>
+            <a:off x="960120" y="2377440"/>
+            <a:ext cx="777240" cy="777240"/>
+          </a:xfrm>
+          <a:prstGeom prst="roundRect">
+            <a:avLst>
+              <a:gd name="adj" fmla="val 18824"/>
+            </a:avLst>
+          </a:prstGeom>
+          <a:solidFill>
+            <a:srgbClr val="2563EB"/>
+          </a:solidFill>
+          <a:ln/>
+        </p:spPr>
+      </p:sp>
+      <p:pic>
+        <p:nvPicPr>
+          <p:cNvPr id="7" name="Image 0" descr="preencoded.png"/>
+          <p:cNvPicPr>
+            <a:picLocks noChangeAspect="1"/>
+          </p:cNvPicPr>
+          <p:nvPr/>
+        </p:nvPicPr>
+        <p:blipFill>
+          <a:blip r:embed="rId3"/>
+          <a:stretch>
+            <a:fillRect/>
+          </a:stretch>
+        </p:blipFill>
+        <p:spPr>
+          <a:xfrm>
+            <a:off x="1133856" y="2551176"/>
+            <a:ext cx="429768" cy="429768"/>
+          </a:xfrm>
+          <a:prstGeom prst="rect">
+            <a:avLst/>
+          </a:prstGeom>
+        </p:spPr>
+      </p:pic>
+      <p:sp>
+        <p:nvSpPr>
+          <p:cNvPr id="8" name="Text 5"/>
+          <p:cNvSpPr/>
+          <p:nvPr/>
+        </p:nvSpPr>
+        <p:spPr>
+          <a:xfrm>
+            <a:off x="960120" y="3291840"/>
+            <a:ext cx="4663440" cy="365760"/>
+          </a:xfrm>
+          <a:prstGeom prst="rect">
+            <a:avLst/>
+          </a:prstGeom>
+          <a:noFill/>
+          <a:ln/>
+        </p:spPr>
+        <p:txBody>
+          <a:bodyPr wrap="square" rtlCol="0" anchor="ctr"/>
+          <a:lstStyle/>
+          <a:p>
+            <a:pPr marL="0" indent="0">
+              <a:buNone/>
+            </a:pPr>
+            <a:r>
+              <a:rPr lang="en-US" sz="1800" b="1" dirty="0">
+                <a:solidFill>
+                  <a:srgbClr val="FFFFFF"/>
+                </a:solidFill>
+                <a:latin typeface="Arial" pitchFamily="34" charset="0"/>
+                <a:ea typeface="Arial" pitchFamily="34" charset="-122"/>
+                <a:cs typeface="Arial" pitchFamily="34" charset="-120"/>
+              </a:rPr>
+              <a:t>Coach Representation</a:t>
+            </a:r>
+            <a:endParaRPr lang="en-US" sz="1800" dirty="0"/>
+          </a:p>
+        </p:txBody>
+      </p:sp>
+      <p:sp>
+        <p:nvSpPr>
+          <p:cNvPr id="9" name="Text 6"/>
+          <p:cNvSpPr/>
+          <p:nvPr/>
+        </p:nvSpPr>
+        <p:spPr>
+          <a:xfrm>
+            <a:off x="960120" y="3675888"/>
+            <a:ext cx="4754880" cy="685800"/>
+          </a:xfrm>
+          <a:prstGeom prst="rect">
+            <a:avLst/>
+          </a:prstGeom>
+          <a:noFill/>
+          <a:ln/>
+        </p:spPr>
+        <p:txBody>
+          <a:bodyPr wrap="square" rtlCol="0" anchor="t"/>
+          <a:lstStyle/>
+          <a:p>
+            <a:pPr marL="0" indent="0">
+              <a:lnSpc>
+                <a:spcPct val="108000"/>
+              </a:lnSpc>
+              <a:buNone/>
+            </a:pPr>
+            <a:r>
+              <a:rPr lang="en-US" sz="1100" dirty="0">
+                <a:solidFill>
+                  <a:srgbClr val="C3CAD6"/>
+                </a:solidFill>
+                <a:latin typeface="Arial" pitchFamily="34" charset="0"/>
+                <a:ea typeface="Arial" pitchFamily="34" charset="-122"/>
+                <a:cs typeface="Arial" pitchFamily="34" charset="-120"/>
+              </a:rPr>
+              <a:t>Contract and career representation for head and assistant coaches in every sport — focused on the women and mid-career assistants the big agencies overlook.</a:t>
+            </a:r>
+            <a:endParaRPr lang="en-US" sz="1100" dirty="0"/>
+          </a:p>
+        </p:txBody>
+      </p:sp>
+      <p:sp>
+        <p:nvSpPr>
+          <p:cNvPr id="10" name="Shape 7"/>
+          <p:cNvSpPr/>
+          <p:nvPr/>
+        </p:nvSpPr>
+        <p:spPr>
+          <a:xfrm>
+            <a:off x="6272784" y="2103120"/>
+            <a:ext cx="5230368" cy="2331720"/>
+          </a:xfrm>
+          <a:prstGeom prst="roundRect">
+            <a:avLst>
+              <a:gd name="adj" fmla="val 4706"/>
+            </a:avLst>
+          </a:prstGeom>
+          <a:solidFill>
+            <a:srgbClr val="2563EB"/>
+          </a:solidFill>
+          <a:ln/>
+        </p:spPr>
+      </p:sp>
+      <p:sp>
+        <p:nvSpPr>
+          <p:cNvPr id="11" name="Shape 8"/>
+          <p:cNvSpPr/>
+          <p:nvPr/>
+        </p:nvSpPr>
+        <p:spPr>
+          <a:xfrm>
+            <a:off x="6547104" y="2377440"/>
+            <a:ext cx="777240" cy="777240"/>
+          </a:xfrm>
+          <a:prstGeom prst="roundRect">
+            <a:avLst>
+              <a:gd name="adj" fmla="val 18824"/>
+            </a:avLst>
+          </a:prstGeom>
+          <a:solidFill>
+            <a:srgbClr val="1D4FD7"/>
+          </a:solidFill>
+          <a:ln w="12700">
+            <a:solidFill>
+              <a:srgbClr val="FFFFFF"/>
+            </a:solidFill>
+            <a:prstDash val="solid"/>
+          </a:ln>
+        </p:spPr>
+      </p:sp>
+      <p:pic>
+        <p:nvPicPr>
+          <p:cNvPr id="12" name="Image 1" descr="preencoded.png"/>
+          <p:cNvPicPr>
+            <a:picLocks noChangeAspect="1"/>
+          </p:cNvPicPr>
+          <p:nvPr/>
+        </p:nvPicPr>
+        <p:blipFill>
+          <a:blip r:embed="rId4"/>
+          <a:stretch>
+            <a:fillRect/>
+          </a:stretch>
+        </p:blipFill>
+        <p:spPr>
+          <a:xfrm>
+            <a:off x="6720840" y="2551176"/>
+            <a:ext cx="429768" cy="429768"/>
+          </a:xfrm>
+          <a:prstGeom prst="rect">
+            <a:avLst/>
+          </a:prstGeom>
+        </p:spPr>
+      </p:pic>
+      <p:sp>
+        <p:nvSpPr>
+          <p:cNvPr id="13" name="Text 9"/>
+          <p:cNvSpPr/>
+          <p:nvPr/>
+        </p:nvSpPr>
+        <p:spPr>
+          <a:xfrm>
+            <a:off x="6547104" y="3291840"/>
+            <a:ext cx="4663440" cy="365760"/>
+          </a:xfrm>
+          <a:prstGeom prst="rect">
+            <a:avLst/>
+          </a:prstGeom>
+          <a:noFill/>
+          <a:ln/>
+        </p:spPr>
+        <p:txBody>
+          <a:bodyPr wrap="square" rtlCol="0" anchor="ctr"/>
+          <a:lstStyle/>
+          <a:p>
+            <a:pPr marL="0" indent="0">
+              <a:buNone/>
+            </a:pPr>
+            <a:r>
+              <a:rPr lang="en-US" sz="1800" b="1" dirty="0">
+                <a:solidFill>
+                  <a:srgbClr val="FFFFFF"/>
+                </a:solidFill>
+                <a:latin typeface="Arial" pitchFamily="34" charset="0"/>
+                <a:ea typeface="Arial" pitchFamily="34" charset="-122"/>
+                <a:cs typeface="Arial" pitchFamily="34" charset="-120"/>
+              </a:rPr>
+              <a:t>NIL &amp; Brand Partnerships</a:t>
+            </a:r>
+            <a:endParaRPr lang="en-US" sz="1800" dirty="0"/>
+          </a:p>
+        </p:txBody>
+      </p:sp>
+      <p:sp>
+        <p:nvSpPr>
+          <p:cNvPr id="14" name="Text 10"/>
+          <p:cNvSpPr/>
+          <p:nvPr/>
+        </p:nvSpPr>
+        <p:spPr>
+          <a:xfrm>
+            <a:off x="6547104" y="3675888"/>
+            <a:ext cx="4754880" cy="685800"/>
+          </a:xfrm>
+          <a:prstGeom prst="rect">
+            <a:avLst/>
+          </a:prstGeom>
+          <a:noFill/>
+          <a:ln/>
+        </p:spPr>
+        <p:txBody>
+          <a:bodyPr wrap="square" rtlCol="0" anchor="t"/>
+          <a:lstStyle/>
+          <a:p>
+            <a:pPr marL="0" indent="0">
+              <a:lnSpc>
+                <a:spcPct val="108000"/>
+              </a:lnSpc>
+              <a:buNone/>
+            </a:pPr>
+            <a:r>
+              <a:rPr lang="en-US" sz="1100" dirty="0">
+                <a:solidFill>
+                  <a:srgbClr val="E7EDFF"/>
+                </a:solidFill>
+                <a:latin typeface="Arial" pitchFamily="34" charset="0"/>
+                <a:ea typeface="Arial" pitchFamily="34" charset="-122"/>
+                <a:cs typeface="Arial" pitchFamily="34" charset="-120"/>
+              </a:rPr>
+              <a:t>Guidance and deal management for athletes and families navigating NIL — a co-equal specialty and the lead engine for the Before You Sign toolkit.</a:t>
+            </a:r>
+            <a:endParaRPr lang="en-US" sz="1100" dirty="0"/>
+          </a:p>
+        </p:txBody>
+      </p:sp>
+      <p:sp>
+        <p:nvSpPr>
+          <p:cNvPr id="15" name="Text 11"/>
+          <p:cNvSpPr/>
+          <p:nvPr/>
+        </p:nvSpPr>
+        <p:spPr>
+          <a:xfrm>
+            <a:off x="685800" y="4709160"/>
+            <a:ext cx="3657600" cy="274320"/>
+          </a:xfrm>
+          <a:prstGeom prst="rect">
+            <a:avLst/>
+          </a:prstGeom>
+          <a:noFill/>
+          <a:ln/>
+        </p:spPr>
+        <p:txBody>
+          <a:bodyPr wrap="square" rtlCol="0" anchor="ctr"/>
+          <a:lstStyle/>
+          <a:p>
+            <a:pPr marL="0" indent="0">
+              <a:buNone/>
+            </a:pPr>
+            <a:r>
+              <a:rPr lang="en-US" sz="1000" b="1" kern="0" spc="200" dirty="0">
+                <a:solidFill>
+                  <a:srgbClr val="6B7280"/>
+                </a:solidFill>
+                <a:latin typeface="Arial" pitchFamily="34" charset="0"/>
+                <a:ea typeface="Arial" pitchFamily="34" charset="-122"/>
+                <a:cs typeface="Arial" pitchFamily="34" charset="-120"/>
+              </a:rPr>
+              <a:t>EXPANSION LINES</a:t>
+            </a:r>
+            <a:endParaRPr lang="en-US" sz="1000" dirty="0"/>
+          </a:p>
+        </p:txBody>
+      </p:sp>
+      <p:sp>
+        <p:nvSpPr>
+          <p:cNvPr id="16" name="Shape 12"/>
+          <p:cNvSpPr/>
+          <p:nvPr/>
+        </p:nvSpPr>
+        <p:spPr>
+          <a:xfrm>
+            <a:off x="685800" y="5029200"/>
+            <a:ext cx="5230368" cy="1051560"/>
+          </a:xfrm>
+          <a:prstGeom prst="roundRect">
+            <a:avLst>
+              <a:gd name="adj" fmla="val 8696"/>
+            </a:avLst>
+          </a:prstGeom>
+          <a:solidFill>
+            <a:srgbClr val="F3F1EA"/>
+          </a:solidFill>
+          <a:ln w="12700">
+            <a:solidFill>
+              <a:srgbClr val="E4E7EC"/>
+            </a:solidFill>
+            <a:prstDash val="solid"/>
+          </a:ln>
+        </p:spPr>
+      </p:sp>
+      <p:sp>
+        <p:nvSpPr>
+          <p:cNvPr id="17" name="Shape 13"/>
+          <p:cNvSpPr/>
+          <p:nvPr/>
+        </p:nvSpPr>
+        <p:spPr>
+          <a:xfrm>
+            <a:off x="914400" y="5239512"/>
+            <a:ext cx="548640" cy="548640"/>
+          </a:xfrm>
+          <a:prstGeom prst="roundRect">
+            <a:avLst>
+              <a:gd name="adj" fmla="val 20000"/>
+            </a:avLst>
+          </a:prstGeom>
+          <a:solidFill>
+            <a:srgbClr val="0B1220"/>
+          </a:solidFill>
+          <a:ln/>
+        </p:spPr>
+      </p:sp>
+      <p:pic>
+        <p:nvPicPr>
+          <p:cNvPr id="18" name="Image 2" descr="preencoded.png"/>
+          <p:cNvPicPr>
+            <a:picLocks noChangeAspect="1"/>
+          </p:cNvPicPr>
+          <p:nvPr/>
+        </p:nvPicPr>
+        <p:blipFill>
+          <a:blip r:embed="rId5"/>
+          <a:stretch>
+            <a:fillRect/>
+          </a:stretch>
+        </p:blipFill>
+        <p:spPr>
+          <a:xfrm>
+            <a:off x="1042416" y="5367528"/>
+            <a:ext cx="292608" cy="292608"/>
+          </a:xfrm>
+          <a:prstGeom prst="rect">
+            <a:avLst/>
+          </a:prstGeom>
+        </p:spPr>
+      </p:pic>
+      <p:sp>
+        <p:nvSpPr>
+          <p:cNvPr id="19" name="Text 14"/>
+          <p:cNvSpPr/>
+          <p:nvPr/>
+        </p:nvSpPr>
+        <p:spPr>
+          <a:xfrm>
+            <a:off x="1645920" y="5230368"/>
+            <a:ext cx="4041648" cy="347472"/>
+          </a:xfrm>
+          <a:prstGeom prst="rect">
+            <a:avLst/>
+          </a:prstGeom>
+          <a:noFill/>
+          <a:ln/>
+        </p:spPr>
+        <p:txBody>
+          <a:bodyPr wrap="square" rtlCol="0" anchor="ctr"/>
+          <a:lstStyle/>
+          <a:p>
+            <a:pPr marL="0" indent="0">
+              <a:buNone/>
+            </a:pPr>
+            <a:r>
+              <a:rPr lang="en-US" sz="1400" b="1" dirty="0">
+                <a:solidFill>
+                  <a:srgbClr val="141A24"/>
+                </a:solidFill>
+                <a:latin typeface="Arial" pitchFamily="34" charset="0"/>
+                <a:ea typeface="Arial" pitchFamily="34" charset="-122"/>
+                <a:cs typeface="Arial" pitchFamily="34" charset="-120"/>
+              </a:rPr>
+              <a:t>Search Desk</a:t>
+            </a:r>
+            <a:endParaRPr lang="en-US" sz="1400" dirty="0"/>
+          </a:p>
+        </p:txBody>
+      </p:sp>
+      <p:sp>
+        <p:nvSpPr>
+          <p:cNvPr id="20" name="Text 15"/>
+          <p:cNvSpPr/>
+          <p:nvPr/>
+        </p:nvSpPr>
+        <p:spPr>
+          <a:xfrm>
+            <a:off x="1645920" y="5577840"/>
+            <a:ext cx="4041648" cy="411480"/>
+          </a:xfrm>
+          <a:prstGeom prst="rect">
+            <a:avLst/>
+          </a:prstGeom>
+          <a:noFill/>
+          <a:ln/>
+        </p:spPr>
+        <p:txBody>
+          <a:bodyPr wrap="square" rtlCol="0" anchor="t"/>
+          <a:lstStyle/>
+          <a:p>
+            <a:pPr marL="0" indent="0">
+              <a:buNone/>
+            </a:pPr>
+            <a:r>
+              <a:rPr lang="en-US" sz="1050" dirty="0">
+                <a:solidFill>
+                  <a:srgbClr val="141A24"/>
+                </a:solidFill>
+                <a:latin typeface="Arial" pitchFamily="34" charset="0"/>
+                <a:ea typeface="Arial" pitchFamily="34" charset="-122"/>
+                <a:cs typeface="Arial" pitchFamily="34" charset="-120"/>
+              </a:rPr>
+              <a:t>Flat-fee searches for mid-major &amp; D-II/III — paid by the school.</a:t>
+            </a:r>
+            <a:endParaRPr lang="en-US" sz="1050" dirty="0"/>
+          </a:p>
+        </p:txBody>
+      </p:sp>
+      <p:sp>
+        <p:nvSpPr>
+          <p:cNvPr id="21" name="Shape 16"/>
+          <p:cNvSpPr/>
+          <p:nvPr/>
+        </p:nvSpPr>
+        <p:spPr>
+          <a:xfrm>
+            <a:off x="6272784" y="5029200"/>
+            <a:ext cx="5230368" cy="1051560"/>
+          </a:xfrm>
+          <a:prstGeom prst="roundRect">
+            <a:avLst>
+              <a:gd name="adj" fmla="val 8696"/>
+            </a:avLst>
+          </a:prstGeom>
+          <a:solidFill>
+            <a:srgbClr val="F3F1EA"/>
+          </a:solidFill>
+          <a:ln w="12700">
+            <a:solidFill>
+              <a:srgbClr val="E4E7EC"/>
+            </a:solidFill>
+            <a:prstDash val="solid"/>
+          </a:ln>
+        </p:spPr>
+      </p:sp>
+      <p:sp>
+        <p:nvSpPr>
+          <p:cNvPr id="22" name="Shape 17"/>
+          <p:cNvSpPr/>
+          <p:nvPr/>
+        </p:nvSpPr>
+        <p:spPr>
+          <a:xfrm>
+            <a:off x="6501384" y="5239512"/>
+            <a:ext cx="548640" cy="548640"/>
+          </a:xfrm>
+          <a:prstGeom prst="roundRect">
+            <a:avLst>
+              <a:gd name="adj" fmla="val 20000"/>
+            </a:avLst>
+          </a:prstGeom>
+          <a:solidFill>
+            <a:srgbClr val="0B1220"/>
+          </a:solidFill>
+          <a:ln/>
+        </p:spPr>
+      </p:sp>
+      <p:pic>
+        <p:nvPicPr>
+          <p:cNvPr id="23" name="Image 3" descr="preencoded.png"/>
+          <p:cNvPicPr>
+            <a:picLocks noChangeAspect="1"/>
+          </p:cNvPicPr>
+          <p:nvPr/>
+        </p:nvPicPr>
+        <p:blipFill>
+          <a:blip r:embed="rId6"/>
+          <a:stretch>
+            <a:fillRect/>
+          </a:stretch>
+        </p:blipFill>
+        <p:spPr>
+          <a:xfrm>
+            <a:off x="6629400" y="5367528"/>
+            <a:ext cx="292608" cy="292608"/>
+          </a:xfrm>
+          <a:prstGeom prst="rect">
+            <a:avLst/>
+          </a:prstGeom>
+        </p:spPr>
+      </p:pic>
+      <p:sp>
+        <p:nvSpPr>
+          <p:cNvPr id="24" name="Text 18"/>
+          <p:cNvSpPr/>
+          <p:nvPr/>
+        </p:nvSpPr>
+        <p:spPr>
+          <a:xfrm>
+            <a:off x="7232904" y="5230368"/>
+            <a:ext cx="4041648" cy="347472"/>
+          </a:xfrm>
+          <a:prstGeom prst="rect">
+            <a:avLst/>
+          </a:prstGeom>
+          <a:noFill/>
+          <a:ln/>
+        </p:spPr>
+        <p:txBody>
+          <a:bodyPr wrap="square" rtlCol="0" anchor="ctr"/>
+          <a:lstStyle/>
+          <a:p>
+            <a:pPr marL="0" indent="0">
+              <a:buNone/>
+            </a:pPr>
+            <a:r>
+              <a:rPr lang="en-US" sz="1400" b="1" dirty="0">
+                <a:solidFill>
+                  <a:srgbClr val="141A24"/>
+                </a:solidFill>
+                <a:latin typeface="Arial" pitchFamily="34" charset="0"/>
+                <a:ea typeface="Arial" pitchFamily="34" charset="-122"/>
+                <a:cs typeface="Arial" pitchFamily="34" charset="-120"/>
+              </a:rPr>
+              <a:t>NFLPA Agent Rep</a:t>
+            </a:r>
+            <a:endParaRPr lang="en-US" sz="1400" dirty="0"/>
+          </a:p>
+        </p:txBody>
+      </p:sp>
+      <p:sp>
+        <p:nvSpPr>
+          <p:cNvPr id="25" name="Text 19"/>
+          <p:cNvSpPr/>
+          <p:nvPr/>
+        </p:nvSpPr>
+        <p:spPr>
+          <a:xfrm>
+            <a:off x="7232904" y="5577840"/>
+            <a:ext cx="4041648" cy="411480"/>
+          </a:xfrm>
+          <a:prstGeom prst="rect">
+            <a:avLst/>
+          </a:prstGeom>
+          <a:noFill/>
+          <a:ln/>
+        </p:spPr>
+        <p:txBody>
+          <a:bodyPr wrap="square" rtlCol="0" anchor="t"/>
+          <a:lstStyle/>
+          <a:p>
+            <a:pPr marL="0" indent="0">
+              <a:buNone/>
+            </a:pPr>
+            <a:r>
+              <a:rPr lang="en-US" sz="1050" dirty="0">
+                <a:solidFill>
+                  <a:srgbClr val="141A24"/>
+                </a:solidFill>
+                <a:latin typeface="Arial" pitchFamily="34" charset="0"/>
+                <a:ea typeface="Arial" pitchFamily="34" charset="-122"/>
+                <a:cs typeface="Arial" pitchFamily="34" charset="-120"/>
+              </a:rPr>
+              <a:t>Represent NFL players once Kim is certified — 3% of contract.</a:t>
+            </a:r>
+            <a:endParaRPr lang="en-US" sz="1050" dirty="0"/>
+          </a:p>
+        </p:txBody>
+      </p:sp>
+      <p:sp>
+        <p:nvSpPr>
+          <p:cNvPr id="26" name="Text 20"/>
+          <p:cNvSpPr/>
+          <p:nvPr/>
+        </p:nvSpPr>
+        <p:spPr>
+          <a:xfrm>
+            <a:off x="685800" y="6400800"/>
+            <a:ext cx="7315200" cy="274320"/>
+          </a:xfrm>
+          <a:prstGeom prst="rect">
+            <a:avLst/>
+          </a:prstGeom>
+          <a:noFill/>
+          <a:ln/>
+        </p:spPr>
+        <p:txBody>
+          <a:bodyPr wrap="square" rtlCol="0" anchor="ctr"/>
+          <a:lstStyle/>
+          <a:p>
+            <a:pPr marL="0" indent="0">
+              <a:buNone/>
+            </a:pPr>
+            <a:r>
+              <a:rPr lang="en-US" sz="850" b="1" dirty="0">
+                <a:solidFill>
+                  <a:srgbClr val="6B7280"/>
+                </a:solidFill>
+                <a:latin typeface="Arial" pitchFamily="34" charset="0"/>
+                <a:ea typeface="Arial" pitchFamily="34" charset="-122"/>
+                <a:cs typeface="Arial" pitchFamily="34" charset="-120"/>
+              </a:rPr>
+              <a:t>Dexter Sports Co.</a:t>
+            </a:r>
+            <a:r>
+              <a:rPr lang="en-US" sz="850" dirty="0">
+                <a:solidFill>
+                  <a:srgbClr val="AEB4BC"/>
+                </a:solidFill>
+                <a:latin typeface="Arial" pitchFamily="34" charset="0"/>
+                <a:ea typeface="Arial" pitchFamily="34" charset="-122"/>
+                <a:cs typeface="Arial" pitchFamily="34" charset="-120"/>
+              </a:rPr>
+              <a:t>   ·   What We Do</a:t>
+            </a:r>
+            <a:endParaRPr lang="en-US" sz="850" dirty="0"/>
+          </a:p>
+        </p:txBody>
+      </p:sp>
+      <p:sp>
+        <p:nvSpPr>
+          <p:cNvPr id="27" name="Text 21"/>
+          <p:cNvSpPr/>
+          <p:nvPr/>
+        </p:nvSpPr>
+        <p:spPr>
+          <a:xfrm>
+            <a:off x="9174175" y="164592"/>
+            <a:ext cx="2788920" cy="228600"/>
+          </a:xfrm>
+          <a:prstGeom prst="rect">
+            <a:avLst/>
+          </a:prstGeom>
+          <a:noFill/>
+          <a:ln/>
+        </p:spPr>
+        <p:txBody>
+          <a:bodyPr wrap="square" rtlCol="0" anchor="ctr"/>
+          <a:lstStyle/>
+          <a:p>
+            <a:pPr marL="0" indent="0" algn="r">
+              <a:buNone/>
+            </a:pPr>
+            <a:r>
+              <a:rPr lang="en-US" sz="750" b="1" kern="0" spc="100" dirty="0">
+                <a:solidFill>
+                  <a:srgbClr val="D4A62A"/>
+                </a:solidFill>
+                <a:latin typeface="Arial" pitchFamily="34" charset="0"/>
+                <a:ea typeface="Arial" pitchFamily="34" charset="-122"/>
+                <a:cs typeface="Arial" pitchFamily="34" charset="-120"/>
+              </a:rPr>
+              <a:t>CONFIDENTIAL · INTERNAL</a:t>
+            </a:r>
+            <a:endParaRPr lang="en-US" sz="750" dirty="0"/>
+          </a:p>
+        </p:txBody>
+      </p:sp>
+    </p:spTree>
+  </p:cSld>
+  <p:clrMapOvr>
+    <a:masterClrMapping/>
+  </p:clrMapOvr>
+</p:sld>
+</file>
+
+<file path=ppt/slides/slide11.xml><?xml version="1.0" encoding="utf-8"?>
+<p:sld xmlns:a="http://schemas.openxmlformats.org/drawingml/2006/main" xmlns:r="http://schemas.openxmlformats.org/officeDocument/2006/relationships" xmlns:p="http://schemas.openxmlformats.org/presentationml/2006/main">
   <p:cSld name="Slide 10">
     <p:bg>
       <p:bgPr>
@@ -3426,7 +4416,7 @@
 </p:sld>
 </file>
 
-<file path=ppt/slides/slide11.xml><?xml version="1.0" encoding="utf-8"?>
+<file path=ppt/slides/slide12.xml><?xml version="1.0" encoding="utf-8"?>
 <p:sld xmlns:a="http://schemas.openxmlformats.org/drawingml/2006/main" xmlns:r="http://schemas.openxmlformats.org/officeDocument/2006/relationships" xmlns:p="http://schemas.openxmlformats.org/presentationml/2006/main">
   <p:cSld name="Slide 11">
     <p:bg>
@@ -4701,7 +5691,7 @@
 </p:sld>
 </file>
 
-<file path=ppt/slides/slide12.xml><?xml version="1.0" encoding="utf-8"?>
+<file path=ppt/slides/slide13.xml><?xml version="1.0" encoding="utf-8"?>
 <p:sld xmlns:a="http://schemas.openxmlformats.org/drawingml/2006/main" xmlns:r="http://schemas.openxmlformats.org/officeDocument/2006/relationships" xmlns:p="http://schemas.openxmlformats.org/presentationml/2006/main">
   <p:cSld name="Slide 12">
     <p:bg>
@@ -5498,7 +6488,7 @@
 </p:sld>
 </file>
 
-<file path=ppt/slides/slide13.xml><?xml version="1.0" encoding="utf-8"?>
+<file path=ppt/slides/slide14.xml><?xml version="1.0" encoding="utf-8"?>
 <p:sld xmlns:a="http://schemas.openxmlformats.org/drawingml/2006/main" xmlns:r="http://schemas.openxmlformats.org/officeDocument/2006/relationships" xmlns:p="http://schemas.openxmlformats.org/presentationml/2006/main">
   <p:cSld name="Slide 13">
     <p:bg>
@@ -6180,7 +7170,7 @@
 </p:sld>
 </file>
 
-<file path=ppt/slides/slide14.xml><?xml version="1.0" encoding="utf-8"?>
+<file path=ppt/slides/slide15.xml><?xml version="1.0" encoding="utf-8"?>
 <p:sld xmlns:a="http://schemas.openxmlformats.org/drawingml/2006/main" xmlns:r="http://schemas.openxmlformats.org/officeDocument/2006/relationships" xmlns:p="http://schemas.openxmlformats.org/presentationml/2006/main">
   <p:cSld name="Slide 14">
     <p:bg>
@@ -6969,7 +7959,7 @@
 </p:sld>
 </file>
 
-<file path=ppt/slides/slide15.xml><?xml version="1.0" encoding="utf-8"?>
+<file path=ppt/slides/slide16.xml><?xml version="1.0" encoding="utf-8"?>
 <p:sld xmlns:a="http://schemas.openxmlformats.org/drawingml/2006/main" xmlns:r="http://schemas.openxmlformats.org/officeDocument/2006/relationships" xmlns:p="http://schemas.openxmlformats.org/presentationml/2006/main">
   <p:cSld name="Slide 15">
     <p:bg>
@@ -9041,7 +10031,7 @@
               <a:buNone/>
             </a:pPr>
             <a:r>
-              <a:rPr lang="en-US" sz="3100" b="1" dirty="0">
+              <a:rPr lang="en-US" sz="3100" b="1">
                 <a:solidFill>
                   <a:srgbClr val="141A24"/>
                 </a:solidFill>
@@ -9049,18 +10039,7 @@
                 <a:ea typeface="Arial" pitchFamily="34" charset="-122"/>
                 <a:cs typeface="Arial" pitchFamily="34" charset="-120"/>
               </a:rPr>
-              <a:t>7.3%</a:t>
-            </a:r>
-            <a:r>
-              <a:rPr lang="en-US" sz="1400" b="1" dirty="0">
-                <a:solidFill>
-                  <a:srgbClr val="6B7280"/>
-                </a:solidFill>
-                <a:latin typeface="Arial" pitchFamily="34" charset="0"/>
-                <a:ea typeface="Arial" pitchFamily="34" charset="-122"/>
-                <a:cs typeface="Arial" pitchFamily="34" charset="-120"/>
-              </a:rPr>
-              <a:t> *</a:t>
+              <a:t>7.3% **</a:t>
             </a:r>
             <a:endParaRPr lang="en-US" sz="3100" dirty="0"/>
           </a:p>
@@ -9437,6 +10416,901 @@
 </file>
 
 <file path=ppt/slides/slide4.xml><?xml version="1.0" encoding="utf-8"?>
+<p:sld xmlns:a="http://schemas.openxmlformats.org/drawingml/2006/main" xmlns:r="http://schemas.openxmlformats.org/officeDocument/2006/relationships" xmlns:p="http://schemas.openxmlformats.org/presentationml/2006/main">
+  <p:cSld name="Slide 3">
+    <p:bg>
+      <p:bgPr>
+        <a:solidFill>
+          <a:srgbClr val="FFFFFF"/>
+        </a:solidFill>
+        <a:effectLst/>
+      </p:bgPr>
+    </p:bg>
+    <p:spTree>
+      <p:nvGrpSpPr>
+        <p:cNvPr id="1" name=""/>
+        <p:cNvGrpSpPr/>
+        <p:nvPr/>
+      </p:nvGrpSpPr>
+      <p:grpSpPr>
+        <a:xfrm>
+          <a:off x="0" y="0"/>
+          <a:ext cx="0" cy="0"/>
+          <a:chOff x="0" y="0"/>
+          <a:chExt cx="0" cy="0"/>
+        </a:xfrm>
+      </p:grpSpPr>
+      <p:sp>
+        <p:nvSpPr>
+          <p:cNvPr id="2" name="Text 0"/>
+          <p:cNvSpPr/>
+          <p:nvPr/>
+        </p:nvSpPr>
+        <p:spPr>
+          <a:xfrm>
+            <a:off x="685800" y="548640"/>
+            <a:ext cx="9144000" cy="274320"/>
+          </a:xfrm>
+          <a:prstGeom prst="rect">
+            <a:avLst/>
+          </a:prstGeom>
+          <a:noFill/>
+          <a:ln/>
+        </p:spPr>
+        <p:txBody>
+          <a:bodyPr wrap="square" rtlCol="0" anchor="ctr"/>
+          <a:lstStyle/>
+          <a:p>
+            <a:pPr marL="0" indent="0">
+              <a:buNone/>
+            </a:pPr>
+            <a:r>
+              <a:rPr lang="en-US" sz="800">
+                <a:solidFill>
+                  <a:srgbClr val="2563EB"/>
+                </a:solidFill>
+                <a:latin typeface="Arial" pitchFamily="34" charset="0"/>
+                <a:ea typeface="Arial" pitchFamily="34" charset="-122"/>
+                <a:cs typeface="Arial" pitchFamily="34" charset="-120"/>
+              </a:rPr>
+              <a:t>● BY THE NUMBERS</a:t>
+            </a:r>
+            <a:endParaRPr lang="en-US" sz="1100" dirty="0"/>
+          </a:p>
+        </p:txBody>
+      </p:sp>
+      <p:sp>
+        <p:nvSpPr>
+          <p:cNvPr id="3" name="Text 1"/>
+          <p:cNvSpPr/>
+          <p:nvPr/>
+        </p:nvSpPr>
+        <p:spPr>
+          <a:xfrm>
+            <a:off x="685800" y="868680"/>
+            <a:ext cx="10789920" cy="640080"/>
+          </a:xfrm>
+          <a:prstGeom prst="rect">
+            <a:avLst/>
+          </a:prstGeom>
+          <a:noFill/>
+          <a:ln/>
+        </p:spPr>
+        <p:txBody>
+          <a:bodyPr wrap="square" rtlCol="0" anchor="ctr"/>
+          <a:lstStyle/>
+          <a:p>
+            <a:pPr marL="0" indent="0">
+              <a:buNone/>
+            </a:pPr>
+            <a:r>
+              <a:rPr lang="en-US" sz="2900" b="1">
+                <a:solidFill>
+                  <a:srgbClr val="141A24"/>
+                </a:solidFill>
+                <a:latin typeface="Arial" pitchFamily="34" charset="0"/>
+                <a:ea typeface="Arial" pitchFamily="34" charset="-122"/>
+                <a:cs typeface="Arial" pitchFamily="34" charset="-120"/>
+              </a:rPr>
+              <a:t>More women in the game than ever.</a:t>
+            </a:r>
+            <a:endParaRPr lang="en-US" sz="2900" dirty="0"/>
+          </a:p>
+        </p:txBody>
+      </p:sp>
+      <p:sp>
+        <p:nvSpPr>
+          <p:cNvPr id="4" name="Text 2"/>
+          <p:cNvSpPr/>
+          <p:nvPr/>
+        </p:nvSpPr>
+        <p:spPr>
+          <a:xfrm>
+            <a:off x="685800" y="1481328"/>
+            <a:ext cx="10789920" cy="365760"/>
+          </a:xfrm>
+          <a:prstGeom prst="rect">
+            <a:avLst/>
+          </a:prstGeom>
+          <a:noFill/>
+          <a:ln/>
+        </p:spPr>
+        <p:txBody>
+          <a:bodyPr wrap="square" rtlCol="0" anchor="ctr"/>
+          <a:lstStyle/>
+          <a:p>
+            <a:pPr marL="0" indent="0">
+              <a:buNone/>
+            </a:pPr>
+            <a:r>
+              <a:rPr lang="en-US" sz="1350" i="1">
+                <a:solidFill>
+                  <a:srgbClr val="6B7280"/>
+                </a:solidFill>
+                <a:latin typeface="Arial" pitchFamily="34" charset="0"/>
+                <a:ea typeface="Arial" pitchFamily="34" charset="-122"/>
+                <a:cs typeface="Arial" pitchFamily="34" charset="-120"/>
+              </a:rPr>
+              <a:t>Record participation and a fast-growing NIL market mean more opportunities, and more contracts and offers that need a careful advocate.</a:t>
+            </a:r>
+            <a:endParaRPr lang="en-US" sz="1350" dirty="0"/>
+          </a:p>
+        </p:txBody>
+      </p:sp>
+      <p:sp>
+        <p:nvSpPr>
+          <p:cNvPr id="5" name="Shape 3"/>
+          <p:cNvSpPr/>
+          <p:nvPr/>
+        </p:nvSpPr>
+        <p:spPr>
+          <a:xfrm>
+            <a:off x="685800" y="2148840"/>
+            <a:ext cx="2606040" cy="2148840"/>
+          </a:xfrm>
+          <a:prstGeom prst="roundRect">
+            <a:avLst>
+              <a:gd name="adj" fmla="val 5106"/>
+            </a:avLst>
+          </a:prstGeom>
+          <a:solidFill>
+            <a:srgbClr val="F3F1EA"/>
+          </a:solidFill>
+          <a:ln w="12700">
+            <a:solidFill>
+              <a:srgbClr val="E4E7EC"/>
+            </a:solidFill>
+            <a:prstDash val="solid"/>
+          </a:ln>
+        </p:spPr>
+        <p:txBody>
+          <a:bodyPr/>
+          <a:lstStyle/>
+          <a:p>
+            <a:endParaRPr lang="en-US"/>
+          </a:p>
+        </p:txBody>
+      </p:sp>
+      <p:pic>
+        <p:nvPicPr>
+          <p:cNvPr id="6" name="Image 0" descr="preencoded.png"/>
+          <p:cNvPicPr>
+            <a:picLocks noChangeAspect="1"/>
+          </p:cNvPicPr>
+          <p:nvPr/>
+        </p:nvPicPr>
+        <p:blipFill>
+          <a:blip r:embed="rId3"/>
+          <a:stretch>
+            <a:fillRect/>
+          </a:stretch>
+        </p:blipFill>
+        <p:spPr>
+          <a:xfrm>
+            <a:off x="960120" y="2423160"/>
+            <a:ext cx="457200" cy="457200"/>
+          </a:xfrm>
+          <a:prstGeom prst="rect">
+            <a:avLst/>
+          </a:prstGeom>
+        </p:spPr>
+      </p:pic>
+      <p:sp>
+        <p:nvSpPr>
+          <p:cNvPr id="7" name="Text 4"/>
+          <p:cNvSpPr/>
+          <p:nvPr/>
+        </p:nvSpPr>
+        <p:spPr>
+          <a:xfrm>
+            <a:off x="914400" y="2926080"/>
+            <a:ext cx="2148840" cy="548640"/>
+          </a:xfrm>
+          <a:prstGeom prst="rect">
+            <a:avLst/>
+          </a:prstGeom>
+          <a:noFill/>
+          <a:ln/>
+        </p:spPr>
+        <p:txBody>
+          <a:bodyPr wrap="square" rtlCol="0" anchor="ctr"/>
+          <a:lstStyle/>
+          <a:p>
+            <a:pPr marL="0" indent="0">
+              <a:buNone/>
+            </a:pPr>
+            <a:r>
+              <a:rPr lang="en-US" sz="3100" b="1">
+                <a:solidFill>
+                  <a:srgbClr val="141A24"/>
+                </a:solidFill>
+                <a:latin typeface="Arial" pitchFamily="34" charset="0"/>
+                <a:ea typeface="Arial" pitchFamily="34" charset="-122"/>
+                <a:cs typeface="Arial" pitchFamily="34" charset="-120"/>
+              </a:rPr>
+              <a:t>242,341 *</a:t>
+            </a:r>
+            <a:endParaRPr lang="en-US" sz="3100" dirty="0"/>
+          </a:p>
+        </p:txBody>
+      </p:sp>
+      <p:sp>
+        <p:nvSpPr>
+          <p:cNvPr id="8" name="Text 5"/>
+          <p:cNvSpPr/>
+          <p:nvPr/>
+        </p:nvSpPr>
+        <p:spPr>
+          <a:xfrm>
+            <a:off x="941832" y="3520440"/>
+            <a:ext cx="2103120" cy="685800"/>
+          </a:xfrm>
+          <a:prstGeom prst="rect">
+            <a:avLst/>
+          </a:prstGeom>
+          <a:noFill/>
+          <a:ln/>
+        </p:spPr>
+        <p:txBody>
+          <a:bodyPr wrap="square" rtlCol="0" anchor="t"/>
+          <a:lstStyle/>
+          <a:p>
+            <a:pPr marL="0" indent="0">
+              <a:lnSpc>
+                <a:spcPct val="105000"/>
+              </a:lnSpc>
+              <a:buNone/>
+            </a:pPr>
+            <a:r>
+              <a:rPr lang="en-US" sz="1050">
+                <a:solidFill>
+                  <a:srgbClr val="141A24"/>
+                </a:solidFill>
+                <a:latin typeface="Arial" pitchFamily="34" charset="0"/>
+                <a:ea typeface="Arial" pitchFamily="34" charset="-122"/>
+                <a:cs typeface="Arial" pitchFamily="34" charset="-120"/>
+              </a:rPr>
+              <a:t>women competed in NCAA sports in 2024–25, a record</a:t>
+            </a:r>
+            <a:endParaRPr lang="en-US" sz="1050" dirty="0"/>
+          </a:p>
+        </p:txBody>
+      </p:sp>
+      <p:sp>
+        <p:nvSpPr>
+          <p:cNvPr id="9" name="Shape 6"/>
+          <p:cNvSpPr/>
+          <p:nvPr/>
+        </p:nvSpPr>
+        <p:spPr>
+          <a:xfrm>
+            <a:off x="3529584" y="2148840"/>
+            <a:ext cx="2606040" cy="2148840"/>
+          </a:xfrm>
+          <a:prstGeom prst="roundRect">
+            <a:avLst>
+              <a:gd name="adj" fmla="val 5106"/>
+            </a:avLst>
+          </a:prstGeom>
+          <a:solidFill>
+            <a:srgbClr val="F3F1EA"/>
+          </a:solidFill>
+          <a:ln w="12700">
+            <a:solidFill>
+              <a:srgbClr val="E4E7EC"/>
+            </a:solidFill>
+            <a:prstDash val="solid"/>
+          </a:ln>
+        </p:spPr>
+        <p:txBody>
+          <a:bodyPr/>
+          <a:lstStyle/>
+          <a:p>
+            <a:endParaRPr lang="en-US"/>
+          </a:p>
+        </p:txBody>
+      </p:sp>
+      <p:pic>
+        <p:nvPicPr>
+          <p:cNvPr id="10" name="Image 1" descr="preencoded.png"/>
+          <p:cNvPicPr>
+            <a:picLocks noChangeAspect="1"/>
+          </p:cNvPicPr>
+          <p:nvPr/>
+        </p:nvPicPr>
+        <p:blipFill>
+          <a:blip r:embed="rId4"/>
+          <a:stretch>
+            <a:fillRect/>
+          </a:stretch>
+        </p:blipFill>
+        <p:spPr>
+          <a:xfrm>
+            <a:off x="3803904" y="2423160"/>
+            <a:ext cx="457200" cy="457200"/>
+          </a:xfrm>
+          <a:prstGeom prst="rect">
+            <a:avLst/>
+          </a:prstGeom>
+        </p:spPr>
+      </p:pic>
+      <p:sp>
+        <p:nvSpPr>
+          <p:cNvPr id="11" name="Text 7"/>
+          <p:cNvSpPr/>
+          <p:nvPr/>
+        </p:nvSpPr>
+        <p:spPr>
+          <a:xfrm>
+            <a:off x="3758184" y="2926080"/>
+            <a:ext cx="2148840" cy="548640"/>
+          </a:xfrm>
+          <a:prstGeom prst="rect">
+            <a:avLst/>
+          </a:prstGeom>
+          <a:noFill/>
+          <a:ln/>
+        </p:spPr>
+        <p:txBody>
+          <a:bodyPr wrap="square" rtlCol="0" anchor="ctr"/>
+          <a:lstStyle/>
+          <a:p>
+            <a:pPr marL="0" indent="0">
+              <a:buNone/>
+            </a:pPr>
+            <a:r>
+              <a:rPr lang="en-US" sz="3100" b="1">
+                <a:solidFill>
+                  <a:srgbClr val="141A24"/>
+                </a:solidFill>
+                <a:latin typeface="Arial" pitchFamily="34" charset="0"/>
+                <a:ea typeface="Arial" pitchFamily="34" charset="-122"/>
+                <a:cs typeface="Arial" pitchFamily="34" charset="-120"/>
+              </a:rPr>
+              <a:t>3.54M **</a:t>
+            </a:r>
+            <a:endParaRPr lang="en-US" sz="3100" dirty="0"/>
+          </a:p>
+        </p:txBody>
+      </p:sp>
+      <p:sp>
+        <p:nvSpPr>
+          <p:cNvPr id="12" name="Text 8"/>
+          <p:cNvSpPr/>
+          <p:nvPr/>
+        </p:nvSpPr>
+        <p:spPr>
+          <a:xfrm>
+            <a:off x="3785616" y="3520440"/>
+            <a:ext cx="2103120" cy="685800"/>
+          </a:xfrm>
+          <a:prstGeom prst="rect">
+            <a:avLst/>
+          </a:prstGeom>
+          <a:noFill/>
+          <a:ln/>
+        </p:spPr>
+        <p:txBody>
+          <a:bodyPr wrap="square" rtlCol="0" anchor="t"/>
+          <a:lstStyle/>
+          <a:p>
+            <a:pPr marL="0" indent="0">
+              <a:lnSpc>
+                <a:spcPct val="105000"/>
+              </a:lnSpc>
+              <a:buNone/>
+            </a:pPr>
+            <a:r>
+              <a:rPr lang="en-US" sz="1050">
+                <a:solidFill>
+                  <a:srgbClr val="141A24"/>
+                </a:solidFill>
+                <a:latin typeface="Arial" pitchFamily="34" charset="0"/>
+                <a:ea typeface="Arial" pitchFamily="34" charset="-122"/>
+                <a:cs typeface="Arial" pitchFamily="34" charset="-120"/>
+              </a:rPr>
+              <a:t>girls played high school sports in 2024–25, also a record</a:t>
+            </a:r>
+            <a:endParaRPr lang="en-US" sz="1050" dirty="0"/>
+          </a:p>
+        </p:txBody>
+      </p:sp>
+      <p:sp>
+        <p:nvSpPr>
+          <p:cNvPr id="13" name="Shape 9"/>
+          <p:cNvSpPr/>
+          <p:nvPr/>
+        </p:nvSpPr>
+        <p:spPr>
+          <a:xfrm>
+            <a:off x="6373368" y="2148840"/>
+            <a:ext cx="2606040" cy="2148840"/>
+          </a:xfrm>
+          <a:prstGeom prst="roundRect">
+            <a:avLst>
+              <a:gd name="adj" fmla="val 5106"/>
+            </a:avLst>
+          </a:prstGeom>
+          <a:solidFill>
+            <a:srgbClr val="F3F1EA"/>
+          </a:solidFill>
+          <a:ln w="12700">
+            <a:solidFill>
+              <a:srgbClr val="E4E7EC"/>
+            </a:solidFill>
+            <a:prstDash val="solid"/>
+          </a:ln>
+        </p:spPr>
+        <p:txBody>
+          <a:bodyPr/>
+          <a:lstStyle/>
+          <a:p>
+            <a:endParaRPr lang="en-US"/>
+          </a:p>
+        </p:txBody>
+      </p:sp>
+      <p:pic>
+        <p:nvPicPr>
+          <p:cNvPr id="14" name="Image 2" descr="preencoded.png"/>
+          <p:cNvPicPr>
+            <a:picLocks noChangeAspect="1"/>
+          </p:cNvPicPr>
+          <p:nvPr/>
+        </p:nvPicPr>
+        <p:blipFill>
+          <a:blip r:embed="rId5"/>
+          <a:stretch>
+            <a:fillRect/>
+          </a:stretch>
+        </p:blipFill>
+        <p:spPr>
+          <a:xfrm>
+            <a:off x="6647688" y="2423160"/>
+            <a:ext cx="457200" cy="457200"/>
+          </a:xfrm>
+          <a:prstGeom prst="rect">
+            <a:avLst/>
+          </a:prstGeom>
+        </p:spPr>
+      </p:pic>
+      <p:sp>
+        <p:nvSpPr>
+          <p:cNvPr id="15" name="Text 10"/>
+          <p:cNvSpPr/>
+          <p:nvPr/>
+        </p:nvSpPr>
+        <p:spPr>
+          <a:xfrm>
+            <a:off x="6601968" y="2926080"/>
+            <a:ext cx="2148840" cy="548640"/>
+          </a:xfrm>
+          <a:prstGeom prst="rect">
+            <a:avLst/>
+          </a:prstGeom>
+          <a:noFill/>
+          <a:ln/>
+        </p:spPr>
+        <p:txBody>
+          <a:bodyPr wrap="square" rtlCol="0" anchor="ctr"/>
+          <a:lstStyle/>
+          <a:p>
+            <a:pPr marL="0" indent="0">
+              <a:buNone/>
+            </a:pPr>
+            <a:r>
+              <a:rPr lang="en-US" sz="3100" b="1">
+                <a:solidFill>
+                  <a:srgbClr val="141A24"/>
+                </a:solidFill>
+                <a:latin typeface="Arial" pitchFamily="34" charset="0"/>
+                <a:ea typeface="Arial" pitchFamily="34" charset="-122"/>
+                <a:cs typeface="Arial" pitchFamily="34" charset="-120"/>
+              </a:rPr>
+              <a:t>$1.67B ***</a:t>
+            </a:r>
+            <a:endParaRPr lang="en-US" sz="3100" dirty="0"/>
+          </a:p>
+        </p:txBody>
+      </p:sp>
+      <p:sp>
+        <p:nvSpPr>
+          <p:cNvPr id="16" name="Text 11"/>
+          <p:cNvSpPr/>
+          <p:nvPr/>
+        </p:nvSpPr>
+        <p:spPr>
+          <a:xfrm>
+            <a:off x="6629400" y="3520440"/>
+            <a:ext cx="2103120" cy="685800"/>
+          </a:xfrm>
+          <a:prstGeom prst="rect">
+            <a:avLst/>
+          </a:prstGeom>
+          <a:noFill/>
+          <a:ln/>
+        </p:spPr>
+        <p:txBody>
+          <a:bodyPr wrap="square" rtlCol="0" anchor="t"/>
+          <a:lstStyle/>
+          <a:p>
+            <a:pPr marL="0" indent="0">
+              <a:lnSpc>
+                <a:spcPct val="105000"/>
+              </a:lnSpc>
+              <a:buNone/>
+            </a:pPr>
+            <a:r>
+              <a:rPr lang="en-US" sz="1050">
+                <a:solidFill>
+                  <a:srgbClr val="141A24"/>
+                </a:solidFill>
+                <a:latin typeface="Arial" pitchFamily="34" charset="0"/>
+                <a:ea typeface="Arial" pitchFamily="34" charset="-122"/>
+                <a:cs typeface="Arial" pitchFamily="34" charset="-120"/>
+              </a:rPr>
+              <a:t>projected NIL market in 2024–25, up from $917M in 2021–22</a:t>
+            </a:r>
+            <a:endParaRPr lang="en-US" sz="1050" dirty="0"/>
+          </a:p>
+        </p:txBody>
+      </p:sp>
+      <p:sp>
+        <p:nvSpPr>
+          <p:cNvPr id="17" name="Shape 12"/>
+          <p:cNvSpPr/>
+          <p:nvPr/>
+        </p:nvSpPr>
+        <p:spPr>
+          <a:xfrm>
+            <a:off x="9217152" y="2148840"/>
+            <a:ext cx="2606040" cy="2148840"/>
+          </a:xfrm>
+          <a:prstGeom prst="roundRect">
+            <a:avLst>
+              <a:gd name="adj" fmla="val 5106"/>
+            </a:avLst>
+          </a:prstGeom>
+          <a:solidFill>
+            <a:srgbClr val="F3F1EA"/>
+          </a:solidFill>
+          <a:ln w="12700">
+            <a:solidFill>
+              <a:srgbClr val="E4E7EC"/>
+            </a:solidFill>
+            <a:prstDash val="solid"/>
+          </a:ln>
+        </p:spPr>
+        <p:txBody>
+          <a:bodyPr/>
+          <a:lstStyle/>
+          <a:p>
+            <a:endParaRPr lang="en-US"/>
+          </a:p>
+        </p:txBody>
+      </p:sp>
+      <p:pic>
+        <p:nvPicPr>
+          <p:cNvPr id="18" name="Image 3" descr="preencoded.png"/>
+          <p:cNvPicPr>
+            <a:picLocks noChangeAspect="1"/>
+          </p:cNvPicPr>
+          <p:nvPr/>
+        </p:nvPicPr>
+        <p:blipFill>
+          <a:blip r:embed="rId6"/>
+          <a:stretch>
+            <a:fillRect/>
+          </a:stretch>
+        </p:blipFill>
+        <p:spPr>
+          <a:xfrm>
+            <a:off x="9491472" y="2423160"/>
+            <a:ext cx="457200" cy="457200"/>
+          </a:xfrm>
+          <a:prstGeom prst="rect">
+            <a:avLst/>
+          </a:prstGeom>
+        </p:spPr>
+      </p:pic>
+      <p:sp>
+        <p:nvSpPr>
+          <p:cNvPr id="19" name="Text 13"/>
+          <p:cNvSpPr/>
+          <p:nvPr/>
+        </p:nvSpPr>
+        <p:spPr>
+          <a:xfrm>
+            <a:off x="9445752" y="2926080"/>
+            <a:ext cx="2148840" cy="548640"/>
+          </a:xfrm>
+          <a:prstGeom prst="rect">
+            <a:avLst/>
+          </a:prstGeom>
+          <a:noFill/>
+          <a:ln/>
+        </p:spPr>
+        <p:txBody>
+          <a:bodyPr wrap="square" rtlCol="0" anchor="ctr"/>
+          <a:lstStyle/>
+          <a:p>
+            <a:pPr marL="0" indent="0">
+              <a:buNone/>
+            </a:pPr>
+            <a:r>
+              <a:rPr lang="en-US" sz="3100" b="1">
+                <a:solidFill>
+                  <a:srgbClr val="141A24"/>
+                </a:solidFill>
+                <a:latin typeface="Arial" pitchFamily="34" charset="0"/>
+                <a:ea typeface="Arial" pitchFamily="34" charset="-122"/>
+                <a:cs typeface="Arial" pitchFamily="34" charset="-120"/>
+              </a:rPr>
+              <a:t>10.2% ***</a:t>
+            </a:r>
+            <a:endParaRPr lang="en-US" sz="3100" dirty="0"/>
+          </a:p>
+        </p:txBody>
+      </p:sp>
+      <p:sp>
+        <p:nvSpPr>
+          <p:cNvPr id="20" name="Text 14"/>
+          <p:cNvSpPr/>
+          <p:nvPr/>
+        </p:nvSpPr>
+        <p:spPr>
+          <a:xfrm>
+            <a:off x="9473184" y="3520440"/>
+            <a:ext cx="2103120" cy="685800"/>
+          </a:xfrm>
+          <a:prstGeom prst="rect">
+            <a:avLst/>
+          </a:prstGeom>
+          <a:noFill/>
+          <a:ln/>
+        </p:spPr>
+        <p:txBody>
+          <a:bodyPr wrap="square" rtlCol="0" anchor="t"/>
+          <a:lstStyle/>
+          <a:p>
+            <a:pPr marL="0" indent="0">
+              <a:lnSpc>
+                <a:spcPct val="105000"/>
+              </a:lnSpc>
+              <a:buNone/>
+            </a:pPr>
+            <a:r>
+              <a:rPr lang="en-US" sz="1050">
+                <a:solidFill>
+                  <a:srgbClr val="141A24"/>
+                </a:solidFill>
+                <a:latin typeface="Arial" pitchFamily="34" charset="0"/>
+                <a:ea typeface="Arial" pitchFamily="34" charset="-122"/>
+                <a:cs typeface="Arial" pitchFamily="34" charset="-120"/>
+              </a:rPr>
+              <a:t>of commercial NIL pay went to women's basketball, passing men's basketball (8.6%)</a:t>
+            </a:r>
+            <a:endParaRPr lang="en-US" sz="1050" dirty="0"/>
+          </a:p>
+        </p:txBody>
+      </p:sp>
+      <p:sp>
+        <p:nvSpPr>
+          <p:cNvPr id="21" name="Shape 15"/>
+          <p:cNvSpPr/>
+          <p:nvPr/>
+        </p:nvSpPr>
+        <p:spPr>
+          <a:xfrm>
+            <a:off x="685800" y="4617720"/>
+            <a:ext cx="10817352" cy="1280160"/>
+          </a:xfrm>
+          <a:prstGeom prst="roundRect">
+            <a:avLst>
+              <a:gd name="adj" fmla="val 8571"/>
+            </a:avLst>
+          </a:prstGeom>
+          <a:solidFill>
+            <a:srgbClr val="0B1220"/>
+          </a:solidFill>
+          <a:ln/>
+        </p:spPr>
+        <p:txBody>
+          <a:bodyPr/>
+          <a:lstStyle/>
+          <a:p>
+            <a:endParaRPr lang="en-US"/>
+          </a:p>
+        </p:txBody>
+      </p:sp>
+      <p:pic>
+        <p:nvPicPr>
+          <p:cNvPr id="22" name="Image 4" descr="preencoded.png"/>
+          <p:cNvPicPr>
+            <a:picLocks noChangeAspect="1"/>
+          </p:cNvPicPr>
+          <p:nvPr/>
+        </p:nvPicPr>
+        <p:blipFill>
+          <a:blip r:embed="rId7"/>
+          <a:stretch>
+            <a:fillRect/>
+          </a:stretch>
+        </p:blipFill>
+        <p:spPr>
+          <a:xfrm>
+            <a:off x="1051560" y="4956048"/>
+            <a:ext cx="566928" cy="566928"/>
+          </a:xfrm>
+          <a:prstGeom prst="rect">
+            <a:avLst/>
+          </a:prstGeom>
+        </p:spPr>
+      </p:pic>
+      <p:sp>
+        <p:nvSpPr>
+          <p:cNvPr id="23" name="Text 16"/>
+          <p:cNvSpPr/>
+          <p:nvPr/>
+        </p:nvSpPr>
+        <p:spPr>
+          <a:xfrm>
+            <a:off x="1874520" y="4773168"/>
+            <a:ext cx="9326880" cy="1005840"/>
+          </a:xfrm>
+          <a:prstGeom prst="rect">
+            <a:avLst/>
+          </a:prstGeom>
+          <a:noFill/>
+          <a:ln/>
+        </p:spPr>
+        <p:txBody>
+          <a:bodyPr wrap="square" rtlCol="0" anchor="ctr"/>
+          <a:lstStyle/>
+          <a:p>
+            <a:pPr marL="0" indent="0">
+              <a:lnSpc>
+                <a:spcPct val="106000"/>
+              </a:lnSpc>
+              <a:buNone/>
+            </a:pPr>
+            <a:r>
+              <a:rPr lang="en-US" sz="1150" b="1">
+                <a:solidFill>
+                  <a:srgbClr val="FFFFFF"/>
+                </a:solidFill>
+                <a:latin typeface="Arial" pitchFamily="34" charset="0"/>
+                <a:ea typeface="Arial" pitchFamily="34" charset="-122"/>
+                <a:cs typeface="Arial" pitchFamily="34" charset="-120"/>
+              </a:rPr>
+              <a:t>Bigger market, uneven share.  </a:t>
+            </a:r>
+            <a:r>
+              <a:rPr lang="en-US" sz="1150">
+                <a:solidFill>
+                  <a:srgbClr val="93B4FF"/>
+                </a:solidFill>
+                <a:latin typeface="Arial" pitchFamily="34" charset="0"/>
+                <a:ea typeface="Arial" pitchFamily="34" charset="-122"/>
+                <a:cs typeface="Arial" pitchFamily="34" charset="-120"/>
+              </a:rPr>
+              <a:t>Brand deals reward women athletes, but donor-funded collectives still send most of their money to football and men's basketball (women's volleyball gets under 1%). Women head coaches grew 13% in a decade to 5,126.* Demand for a careful advocate is growing on both sides.</a:t>
+            </a:r>
+            <a:endParaRPr lang="en-US" sz="1150" dirty="0"/>
+          </a:p>
+        </p:txBody>
+      </p:sp>
+      <p:sp>
+        <p:nvSpPr>
+          <p:cNvPr id="24" name="Text 17"/>
+          <p:cNvSpPr/>
+          <p:nvPr/>
+        </p:nvSpPr>
+        <p:spPr>
+          <a:xfrm>
+            <a:off x="685800" y="6455664"/>
+            <a:ext cx="10789920" cy="274320"/>
+          </a:xfrm>
+          <a:prstGeom prst="rect">
+            <a:avLst/>
+          </a:prstGeom>
+          <a:noFill/>
+          <a:ln/>
+        </p:spPr>
+        <p:txBody>
+          <a:bodyPr wrap="square" rtlCol="0" anchor="ctr"/>
+          <a:lstStyle/>
+          <a:p>
+            <a:pPr marL="0" indent="0">
+              <a:buNone/>
+            </a:pPr>
+            <a:r>
+              <a:rPr lang="en-US" sz="700" i="1">
+                <a:solidFill>
+                  <a:srgbClr val="6B7280"/>
+                </a:solidFill>
+                <a:latin typeface="Arial" pitchFamily="34" charset="0"/>
+                <a:ea typeface="Arial" pitchFamily="34" charset="-122"/>
+                <a:cs typeface="Arial" pitchFamily="34" charset="-120"/>
+              </a:rPr>
+              <a:t>* NCAA, Sports Sponsorship and Participation Rates Report (2024–25) and Demographics Database (2025), via NCAA.org.  ** NFHS, High School Athletics Participation Survey 2024–25 (Sept 2025).  *** Opendorse, NIL at 3: The Annual Opendorse Report (July 2024); market figures are Opendorse projections.</a:t>
+            </a:r>
+            <a:endParaRPr lang="en-US" sz="700" dirty="0"/>
+          </a:p>
+        </p:txBody>
+      </p:sp>
+      <p:sp>
+        <p:nvSpPr>
+          <p:cNvPr id="25" name="Text 18"/>
+          <p:cNvSpPr/>
+          <p:nvPr/>
+        </p:nvSpPr>
+        <p:spPr>
+          <a:xfrm>
+            <a:off x="9174175" y="164592"/>
+            <a:ext cx="2788920" cy="228600"/>
+          </a:xfrm>
+          <a:prstGeom prst="rect">
+            <a:avLst/>
+          </a:prstGeom>
+          <a:noFill/>
+          <a:ln/>
+        </p:spPr>
+        <p:txBody>
+          <a:bodyPr wrap="square" rtlCol="0" anchor="ctr"/>
+          <a:lstStyle/>
+          <a:p>
+            <a:pPr marL="0" indent="0" algn="r">
+              <a:buNone/>
+            </a:pPr>
+            <a:r>
+              <a:rPr lang="en-US" sz="750" b="1" kern="0" spc="100" dirty="0">
+                <a:solidFill>
+                  <a:srgbClr val="D4A62A"/>
+                </a:solidFill>
+                <a:latin typeface="Arial" pitchFamily="34" charset="0"/>
+                <a:ea typeface="Arial" pitchFamily="34" charset="-122"/>
+                <a:cs typeface="Arial" pitchFamily="34" charset="-120"/>
+              </a:rPr>
+              <a:t>CONFIDENTIAL · INTERNAL</a:t>
+            </a:r>
+            <a:endParaRPr lang="en-US" sz="750" dirty="0"/>
+          </a:p>
+        </p:txBody>
+      </p:sp>
+    </p:spTree>
+    <p:extLst>
+      <p:ext uri="{BB962C8B-B14F-4D97-AF65-F5344CB8AC3E}">
+        <p14:creationId xmlns:p14="http://schemas.microsoft.com/office/powerpoint/2010/main" val="484646047"/>
+      </p:ext>
+    </p:extLst>
+  </p:cSld>
+  <p:clrMapOvr>
+    <a:masterClrMapping/>
+  </p:clrMapOvr>
+</p:sld>
+</file>
+
+<file path=ppt/slides/slide5.xml><?xml version="1.0" encoding="utf-8"?>
 <p:sld xmlns:a="http://schemas.openxmlformats.org/drawingml/2006/main" xmlns:r="http://schemas.openxmlformats.org/officeDocument/2006/relationships" xmlns:p="http://schemas.openxmlformats.org/presentationml/2006/main">
   <p:cSld name="Slide 4">
     <p:bg>
@@ -10484,7 +12358,7 @@
 </p:sld>
 </file>
 
-<file path=ppt/slides/slide5.xml><?xml version="1.0" encoding="utf-8"?>
+<file path=ppt/slides/slide6.xml><?xml version="1.0" encoding="utf-8"?>
 <p:sld xmlns:a="http://schemas.openxmlformats.org/drawingml/2006/main" xmlns:r="http://schemas.openxmlformats.org/officeDocument/2006/relationships" xmlns:p="http://schemas.openxmlformats.org/presentationml/2006/main">
   <p:cSld name="Slide 5">
     <p:bg>
@@ -12821,7 +14695,7 @@
 </p:sld>
 </file>
 
-<file path=ppt/slides/slide6.xml><?xml version="1.0" encoding="utf-8"?>
+<file path=ppt/slides/slide7.xml><?xml version="1.0" encoding="utf-8"?>
 <p:sld xmlns:a="http://schemas.openxmlformats.org/drawingml/2006/main" xmlns:r="http://schemas.openxmlformats.org/officeDocument/2006/relationships" xmlns:p="http://schemas.openxmlformats.org/presentationml/2006/main">
   <p:cSld name="Slide 6">
     <p:bg>
@@ -13881,7 +15755,7 @@
 </p:sld>
 </file>
 
-<file path=ppt/slides/slide7.xml><?xml version="1.0" encoding="utf-8"?>
+<file path=ppt/slides/slide8.xml><?xml version="1.0" encoding="utf-8"?>
 <p:sld xmlns:a="http://schemas.openxmlformats.org/drawingml/2006/main" xmlns:r="http://schemas.openxmlformats.org/officeDocument/2006/relationships" xmlns:p="http://schemas.openxmlformats.org/presentationml/2006/main">
   <p:cSld name="Slide 7">
     <p:bg>
@@ -14796,7 +16670,7 @@
 </p:sld>
 </file>
 
-<file path=ppt/slides/slide8.xml><?xml version="1.0" encoding="utf-8"?>
+<file path=ppt/slides/slide9.xml><?xml version="1.0" encoding="utf-8"?>
 <p:sld xmlns:a="http://schemas.openxmlformats.org/drawingml/2006/main" xmlns:r="http://schemas.openxmlformats.org/officeDocument/2006/relationships" xmlns:p="http://schemas.openxmlformats.org/presentationml/2006/main">
   <p:cSld name="Slide 8">
     <p:bg>
@@ -15797,911 +17671,6 @@
       <p:sp>
         <p:nvSpPr>
           <p:cNvPr id="30" name="Text 24"/>
-          <p:cNvSpPr/>
-          <p:nvPr/>
-        </p:nvSpPr>
-        <p:spPr>
-          <a:xfrm>
-            <a:off x="9174175" y="164592"/>
-            <a:ext cx="2788920" cy="228600"/>
-          </a:xfrm>
-          <a:prstGeom prst="rect">
-            <a:avLst/>
-          </a:prstGeom>
-          <a:noFill/>
-          <a:ln/>
-        </p:spPr>
-        <p:txBody>
-          <a:bodyPr wrap="square" rtlCol="0" anchor="ctr"/>
-          <a:lstStyle/>
-          <a:p>
-            <a:pPr marL="0" indent="0" algn="r">
-              <a:buNone/>
-            </a:pPr>
-            <a:r>
-              <a:rPr lang="en-US" sz="750" b="1" kern="0" spc="100" dirty="0">
-                <a:solidFill>
-                  <a:srgbClr val="D4A62A"/>
-                </a:solidFill>
-                <a:latin typeface="Arial" pitchFamily="34" charset="0"/>
-                <a:ea typeface="Arial" pitchFamily="34" charset="-122"/>
-                <a:cs typeface="Arial" pitchFamily="34" charset="-120"/>
-              </a:rPr>
-              <a:t>CONFIDENTIAL · INTERNAL</a:t>
-            </a:r>
-            <a:endParaRPr lang="en-US" sz="750" dirty="0"/>
-          </a:p>
-        </p:txBody>
-      </p:sp>
-    </p:spTree>
-  </p:cSld>
-  <p:clrMapOvr>
-    <a:masterClrMapping/>
-  </p:clrMapOvr>
-</p:sld>
-</file>
-
-<file path=ppt/slides/slide9.xml><?xml version="1.0" encoding="utf-8"?>
-<p:sld xmlns:a="http://schemas.openxmlformats.org/drawingml/2006/main" xmlns:r="http://schemas.openxmlformats.org/officeDocument/2006/relationships" xmlns:p="http://schemas.openxmlformats.org/presentationml/2006/main">
-  <p:cSld name="Slide 9">
-    <p:bg>
-      <p:bgPr>
-        <a:solidFill>
-          <a:srgbClr val="FFFFFF"/>
-        </a:solidFill>
-        <a:effectLst/>
-      </p:bgPr>
-    </p:bg>
-    <p:spTree>
-      <p:nvGrpSpPr>
-        <p:cNvPr id="1" name=""/>
-        <p:cNvGrpSpPr/>
-        <p:nvPr/>
-      </p:nvGrpSpPr>
-      <p:grpSpPr>
-        <a:xfrm>
-          <a:off x="0" y="0"/>
-          <a:ext cx="0" cy="0"/>
-          <a:chOff x="0" y="0"/>
-          <a:chExt cx="0" cy="0"/>
-        </a:xfrm>
-      </p:grpSpPr>
-      <p:sp>
-        <p:nvSpPr>
-          <p:cNvPr id="2" name="Text 0"/>
-          <p:cNvSpPr/>
-          <p:nvPr/>
-        </p:nvSpPr>
-        <p:spPr>
-          <a:xfrm>
-            <a:off x="685800" y="548640"/>
-            <a:ext cx="9144000" cy="274320"/>
-          </a:xfrm>
-          <a:prstGeom prst="rect">
-            <a:avLst/>
-          </a:prstGeom>
-          <a:noFill/>
-          <a:ln/>
-        </p:spPr>
-        <p:txBody>
-          <a:bodyPr wrap="square" rtlCol="0" anchor="ctr"/>
-          <a:lstStyle/>
-          <a:p>
-            <a:pPr marL="0" indent="0">
-              <a:buNone/>
-            </a:pPr>
-            <a:r>
-              <a:rPr lang="en-US" sz="800" dirty="0">
-                <a:solidFill>
-                  <a:srgbClr val="2563EB"/>
-                </a:solidFill>
-                <a:latin typeface="Arial" pitchFamily="34" charset="0"/>
-                <a:ea typeface="Arial" pitchFamily="34" charset="-122"/>
-                <a:cs typeface="Arial" pitchFamily="34" charset="-120"/>
-              </a:rPr>
-              <a:t>● </a:t>
-            </a:r>
-            <a:r>
-              <a:rPr lang="en-US" sz="1100" b="1" kern="0" spc="300" dirty="0">
-                <a:solidFill>
-                  <a:srgbClr val="2563EB"/>
-                </a:solidFill>
-                <a:latin typeface="Arial" pitchFamily="34" charset="0"/>
-                <a:ea typeface="Arial" pitchFamily="34" charset="-122"/>
-                <a:cs typeface="Arial" pitchFamily="34" charset="-120"/>
-              </a:rPr>
-              <a:t>WHAT WE DO</a:t>
-            </a:r>
-            <a:endParaRPr lang="en-US" sz="1100" dirty="0"/>
-          </a:p>
-        </p:txBody>
-      </p:sp>
-      <p:sp>
-        <p:nvSpPr>
-          <p:cNvPr id="3" name="Text 1"/>
-          <p:cNvSpPr/>
-          <p:nvPr/>
-        </p:nvSpPr>
-        <p:spPr>
-          <a:xfrm>
-            <a:off x="685800" y="868680"/>
-            <a:ext cx="10789920" cy="640080"/>
-          </a:xfrm>
-          <a:prstGeom prst="rect">
-            <a:avLst/>
-          </a:prstGeom>
-          <a:noFill/>
-          <a:ln/>
-        </p:spPr>
-        <p:txBody>
-          <a:bodyPr wrap="square" rtlCol="0" anchor="ctr"/>
-          <a:lstStyle/>
-          <a:p>
-            <a:pPr marL="0" indent="0">
-              <a:buNone/>
-            </a:pPr>
-            <a:r>
-              <a:rPr lang="en-US" sz="2900" b="1" dirty="0">
-                <a:solidFill>
-                  <a:srgbClr val="141A24"/>
-                </a:solidFill>
-                <a:latin typeface="Arial" pitchFamily="34" charset="0"/>
-                <a:ea typeface="Arial" pitchFamily="34" charset="-122"/>
-                <a:cs typeface="Arial" pitchFamily="34" charset="-120"/>
-              </a:rPr>
-              <a:t>Two specialties. </a:t>
-            </a:r>
-            <a:r>
-              <a:rPr lang="en-US" sz="2900" i="1" dirty="0">
-                <a:solidFill>
-                  <a:srgbClr val="2563EB"/>
-                </a:solidFill>
-                <a:latin typeface="Georgia" pitchFamily="34" charset="0"/>
-                <a:ea typeface="Georgia" pitchFamily="34" charset="-122"/>
-                <a:cs typeface="Georgia" pitchFamily="34" charset="-120"/>
-              </a:rPr>
-              <a:t>One advocate.</a:t>
-            </a:r>
-            <a:endParaRPr lang="en-US" sz="2900" dirty="0"/>
-          </a:p>
-        </p:txBody>
-      </p:sp>
-      <p:sp>
-        <p:nvSpPr>
-          <p:cNvPr id="4" name="Text 2"/>
-          <p:cNvSpPr/>
-          <p:nvPr/>
-        </p:nvSpPr>
-        <p:spPr>
-          <a:xfrm>
-            <a:off x="685800" y="1481328"/>
-            <a:ext cx="10789920" cy="365760"/>
-          </a:xfrm>
-          <a:prstGeom prst="rect">
-            <a:avLst/>
-          </a:prstGeom>
-          <a:noFill/>
-          <a:ln/>
-        </p:spPr>
-        <p:txBody>
-          <a:bodyPr wrap="square" rtlCol="0" anchor="ctr"/>
-          <a:lstStyle/>
-          <a:p>
-            <a:pPr marL="0" indent="0">
-              <a:buNone/>
-            </a:pPr>
-            <a:r>
-              <a:rPr lang="en-US" sz="1350" i="1" dirty="0">
-                <a:solidFill>
-                  <a:srgbClr val="6B7280"/>
-                </a:solidFill>
-                <a:latin typeface="Arial" pitchFamily="34" charset="0"/>
-                <a:ea typeface="Arial" pitchFamily="34" charset="-122"/>
-                <a:cs typeface="Arial" pitchFamily="34" charset="-120"/>
-              </a:rPr>
-              <a:t>From the next contract to the first NIL offer — coach representation and NIL guidance are the co-equal core.</a:t>
-            </a:r>
-            <a:endParaRPr lang="en-US" sz="1350" dirty="0"/>
-          </a:p>
-        </p:txBody>
-      </p:sp>
-      <p:sp>
-        <p:nvSpPr>
-          <p:cNvPr id="5" name="Shape 3"/>
-          <p:cNvSpPr/>
-          <p:nvPr/>
-        </p:nvSpPr>
-        <p:spPr>
-          <a:xfrm>
-            <a:off x="685800" y="2103120"/>
-            <a:ext cx="5230368" cy="2331720"/>
-          </a:xfrm>
-          <a:prstGeom prst="roundRect">
-            <a:avLst>
-              <a:gd name="adj" fmla="val 4706"/>
-            </a:avLst>
-          </a:prstGeom>
-          <a:solidFill>
-            <a:srgbClr val="0B1220"/>
-          </a:solidFill>
-          <a:ln/>
-        </p:spPr>
-      </p:sp>
-      <p:sp>
-        <p:nvSpPr>
-          <p:cNvPr id="6" name="Shape 4"/>
-          <p:cNvSpPr/>
-          <p:nvPr/>
-        </p:nvSpPr>
-        <p:spPr>
-          <a:xfrm>
-            <a:off x="960120" y="2377440"/>
-            <a:ext cx="777240" cy="777240"/>
-          </a:xfrm>
-          <a:prstGeom prst="roundRect">
-            <a:avLst>
-              <a:gd name="adj" fmla="val 18824"/>
-            </a:avLst>
-          </a:prstGeom>
-          <a:solidFill>
-            <a:srgbClr val="2563EB"/>
-          </a:solidFill>
-          <a:ln/>
-        </p:spPr>
-      </p:sp>
-      <p:pic>
-        <p:nvPicPr>
-          <p:cNvPr id="7" name="Image 0" descr="preencoded.png"/>
-          <p:cNvPicPr>
-            <a:picLocks noChangeAspect="1"/>
-          </p:cNvPicPr>
-          <p:nvPr/>
-        </p:nvPicPr>
-        <p:blipFill>
-          <a:blip r:embed="rId3"/>
-          <a:stretch>
-            <a:fillRect/>
-          </a:stretch>
-        </p:blipFill>
-        <p:spPr>
-          <a:xfrm>
-            <a:off x="1133856" y="2551176"/>
-            <a:ext cx="429768" cy="429768"/>
-          </a:xfrm>
-          <a:prstGeom prst="rect">
-            <a:avLst/>
-          </a:prstGeom>
-        </p:spPr>
-      </p:pic>
-      <p:sp>
-        <p:nvSpPr>
-          <p:cNvPr id="8" name="Text 5"/>
-          <p:cNvSpPr/>
-          <p:nvPr/>
-        </p:nvSpPr>
-        <p:spPr>
-          <a:xfrm>
-            <a:off x="960120" y="3291840"/>
-            <a:ext cx="4663440" cy="365760"/>
-          </a:xfrm>
-          <a:prstGeom prst="rect">
-            <a:avLst/>
-          </a:prstGeom>
-          <a:noFill/>
-          <a:ln/>
-        </p:spPr>
-        <p:txBody>
-          <a:bodyPr wrap="square" rtlCol="0" anchor="ctr"/>
-          <a:lstStyle/>
-          <a:p>
-            <a:pPr marL="0" indent="0">
-              <a:buNone/>
-            </a:pPr>
-            <a:r>
-              <a:rPr lang="en-US" sz="1800" b="1" dirty="0">
-                <a:solidFill>
-                  <a:srgbClr val="FFFFFF"/>
-                </a:solidFill>
-                <a:latin typeface="Arial" pitchFamily="34" charset="0"/>
-                <a:ea typeface="Arial" pitchFamily="34" charset="-122"/>
-                <a:cs typeface="Arial" pitchFamily="34" charset="-120"/>
-              </a:rPr>
-              <a:t>Coach Representation</a:t>
-            </a:r>
-            <a:endParaRPr lang="en-US" sz="1800" dirty="0"/>
-          </a:p>
-        </p:txBody>
-      </p:sp>
-      <p:sp>
-        <p:nvSpPr>
-          <p:cNvPr id="9" name="Text 6"/>
-          <p:cNvSpPr/>
-          <p:nvPr/>
-        </p:nvSpPr>
-        <p:spPr>
-          <a:xfrm>
-            <a:off x="960120" y="3675888"/>
-            <a:ext cx="4754880" cy="685800"/>
-          </a:xfrm>
-          <a:prstGeom prst="rect">
-            <a:avLst/>
-          </a:prstGeom>
-          <a:noFill/>
-          <a:ln/>
-        </p:spPr>
-        <p:txBody>
-          <a:bodyPr wrap="square" rtlCol="0" anchor="t"/>
-          <a:lstStyle/>
-          <a:p>
-            <a:pPr marL="0" indent="0">
-              <a:lnSpc>
-                <a:spcPct val="108000"/>
-              </a:lnSpc>
-              <a:buNone/>
-            </a:pPr>
-            <a:r>
-              <a:rPr lang="en-US" sz="1100" dirty="0">
-                <a:solidFill>
-                  <a:srgbClr val="C3CAD6"/>
-                </a:solidFill>
-                <a:latin typeface="Arial" pitchFamily="34" charset="0"/>
-                <a:ea typeface="Arial" pitchFamily="34" charset="-122"/>
-                <a:cs typeface="Arial" pitchFamily="34" charset="-120"/>
-              </a:rPr>
-              <a:t>Contract and career representation for head and assistant coaches in every sport — focused on the women and mid-career assistants the big agencies overlook.</a:t>
-            </a:r>
-            <a:endParaRPr lang="en-US" sz="1100" dirty="0"/>
-          </a:p>
-        </p:txBody>
-      </p:sp>
-      <p:sp>
-        <p:nvSpPr>
-          <p:cNvPr id="10" name="Shape 7"/>
-          <p:cNvSpPr/>
-          <p:nvPr/>
-        </p:nvSpPr>
-        <p:spPr>
-          <a:xfrm>
-            <a:off x="6272784" y="2103120"/>
-            <a:ext cx="5230368" cy="2331720"/>
-          </a:xfrm>
-          <a:prstGeom prst="roundRect">
-            <a:avLst>
-              <a:gd name="adj" fmla="val 4706"/>
-            </a:avLst>
-          </a:prstGeom>
-          <a:solidFill>
-            <a:srgbClr val="2563EB"/>
-          </a:solidFill>
-          <a:ln/>
-        </p:spPr>
-      </p:sp>
-      <p:sp>
-        <p:nvSpPr>
-          <p:cNvPr id="11" name="Shape 8"/>
-          <p:cNvSpPr/>
-          <p:nvPr/>
-        </p:nvSpPr>
-        <p:spPr>
-          <a:xfrm>
-            <a:off x="6547104" y="2377440"/>
-            <a:ext cx="777240" cy="777240"/>
-          </a:xfrm>
-          <a:prstGeom prst="roundRect">
-            <a:avLst>
-              <a:gd name="adj" fmla="val 18824"/>
-            </a:avLst>
-          </a:prstGeom>
-          <a:solidFill>
-            <a:srgbClr val="1D4FD7"/>
-          </a:solidFill>
-          <a:ln w="12700">
-            <a:solidFill>
-              <a:srgbClr val="FFFFFF"/>
-            </a:solidFill>
-            <a:prstDash val="solid"/>
-          </a:ln>
-        </p:spPr>
-      </p:sp>
-      <p:pic>
-        <p:nvPicPr>
-          <p:cNvPr id="12" name="Image 1" descr="preencoded.png"/>
-          <p:cNvPicPr>
-            <a:picLocks noChangeAspect="1"/>
-          </p:cNvPicPr>
-          <p:nvPr/>
-        </p:nvPicPr>
-        <p:blipFill>
-          <a:blip r:embed="rId4"/>
-          <a:stretch>
-            <a:fillRect/>
-          </a:stretch>
-        </p:blipFill>
-        <p:spPr>
-          <a:xfrm>
-            <a:off x="6720840" y="2551176"/>
-            <a:ext cx="429768" cy="429768"/>
-          </a:xfrm>
-          <a:prstGeom prst="rect">
-            <a:avLst/>
-          </a:prstGeom>
-        </p:spPr>
-      </p:pic>
-      <p:sp>
-        <p:nvSpPr>
-          <p:cNvPr id="13" name="Text 9"/>
-          <p:cNvSpPr/>
-          <p:nvPr/>
-        </p:nvSpPr>
-        <p:spPr>
-          <a:xfrm>
-            <a:off x="6547104" y="3291840"/>
-            <a:ext cx="4663440" cy="365760"/>
-          </a:xfrm>
-          <a:prstGeom prst="rect">
-            <a:avLst/>
-          </a:prstGeom>
-          <a:noFill/>
-          <a:ln/>
-        </p:spPr>
-        <p:txBody>
-          <a:bodyPr wrap="square" rtlCol="0" anchor="ctr"/>
-          <a:lstStyle/>
-          <a:p>
-            <a:pPr marL="0" indent="0">
-              <a:buNone/>
-            </a:pPr>
-            <a:r>
-              <a:rPr lang="en-US" sz="1800" b="1" dirty="0">
-                <a:solidFill>
-                  <a:srgbClr val="FFFFFF"/>
-                </a:solidFill>
-                <a:latin typeface="Arial" pitchFamily="34" charset="0"/>
-                <a:ea typeface="Arial" pitchFamily="34" charset="-122"/>
-                <a:cs typeface="Arial" pitchFamily="34" charset="-120"/>
-              </a:rPr>
-              <a:t>NIL &amp; Brand Partnerships</a:t>
-            </a:r>
-            <a:endParaRPr lang="en-US" sz="1800" dirty="0"/>
-          </a:p>
-        </p:txBody>
-      </p:sp>
-      <p:sp>
-        <p:nvSpPr>
-          <p:cNvPr id="14" name="Text 10"/>
-          <p:cNvSpPr/>
-          <p:nvPr/>
-        </p:nvSpPr>
-        <p:spPr>
-          <a:xfrm>
-            <a:off x="6547104" y="3675888"/>
-            <a:ext cx="4754880" cy="685800"/>
-          </a:xfrm>
-          <a:prstGeom prst="rect">
-            <a:avLst/>
-          </a:prstGeom>
-          <a:noFill/>
-          <a:ln/>
-        </p:spPr>
-        <p:txBody>
-          <a:bodyPr wrap="square" rtlCol="0" anchor="t"/>
-          <a:lstStyle/>
-          <a:p>
-            <a:pPr marL="0" indent="0">
-              <a:lnSpc>
-                <a:spcPct val="108000"/>
-              </a:lnSpc>
-              <a:buNone/>
-            </a:pPr>
-            <a:r>
-              <a:rPr lang="en-US" sz="1100" dirty="0">
-                <a:solidFill>
-                  <a:srgbClr val="E7EDFF"/>
-                </a:solidFill>
-                <a:latin typeface="Arial" pitchFamily="34" charset="0"/>
-                <a:ea typeface="Arial" pitchFamily="34" charset="-122"/>
-                <a:cs typeface="Arial" pitchFamily="34" charset="-120"/>
-              </a:rPr>
-              <a:t>Guidance and deal management for athletes and families navigating NIL — a co-equal specialty and the lead engine for the Before You Sign toolkit.</a:t>
-            </a:r>
-            <a:endParaRPr lang="en-US" sz="1100" dirty="0"/>
-          </a:p>
-        </p:txBody>
-      </p:sp>
-      <p:sp>
-        <p:nvSpPr>
-          <p:cNvPr id="15" name="Text 11"/>
-          <p:cNvSpPr/>
-          <p:nvPr/>
-        </p:nvSpPr>
-        <p:spPr>
-          <a:xfrm>
-            <a:off x="685800" y="4709160"/>
-            <a:ext cx="3657600" cy="274320"/>
-          </a:xfrm>
-          <a:prstGeom prst="rect">
-            <a:avLst/>
-          </a:prstGeom>
-          <a:noFill/>
-          <a:ln/>
-        </p:spPr>
-        <p:txBody>
-          <a:bodyPr wrap="square" rtlCol="0" anchor="ctr"/>
-          <a:lstStyle/>
-          <a:p>
-            <a:pPr marL="0" indent="0">
-              <a:buNone/>
-            </a:pPr>
-            <a:r>
-              <a:rPr lang="en-US" sz="1000" b="1" kern="0" spc="200" dirty="0">
-                <a:solidFill>
-                  <a:srgbClr val="6B7280"/>
-                </a:solidFill>
-                <a:latin typeface="Arial" pitchFamily="34" charset="0"/>
-                <a:ea typeface="Arial" pitchFamily="34" charset="-122"/>
-                <a:cs typeface="Arial" pitchFamily="34" charset="-120"/>
-              </a:rPr>
-              <a:t>EXPANSION LINES</a:t>
-            </a:r>
-            <a:endParaRPr lang="en-US" sz="1000" dirty="0"/>
-          </a:p>
-        </p:txBody>
-      </p:sp>
-      <p:sp>
-        <p:nvSpPr>
-          <p:cNvPr id="16" name="Shape 12"/>
-          <p:cNvSpPr/>
-          <p:nvPr/>
-        </p:nvSpPr>
-        <p:spPr>
-          <a:xfrm>
-            <a:off x="685800" y="5029200"/>
-            <a:ext cx="5230368" cy="1051560"/>
-          </a:xfrm>
-          <a:prstGeom prst="roundRect">
-            <a:avLst>
-              <a:gd name="adj" fmla="val 8696"/>
-            </a:avLst>
-          </a:prstGeom>
-          <a:solidFill>
-            <a:srgbClr val="F3F1EA"/>
-          </a:solidFill>
-          <a:ln w="12700">
-            <a:solidFill>
-              <a:srgbClr val="E4E7EC"/>
-            </a:solidFill>
-            <a:prstDash val="solid"/>
-          </a:ln>
-        </p:spPr>
-      </p:sp>
-      <p:sp>
-        <p:nvSpPr>
-          <p:cNvPr id="17" name="Shape 13"/>
-          <p:cNvSpPr/>
-          <p:nvPr/>
-        </p:nvSpPr>
-        <p:spPr>
-          <a:xfrm>
-            <a:off x="914400" y="5239512"/>
-            <a:ext cx="548640" cy="548640"/>
-          </a:xfrm>
-          <a:prstGeom prst="roundRect">
-            <a:avLst>
-              <a:gd name="adj" fmla="val 20000"/>
-            </a:avLst>
-          </a:prstGeom>
-          <a:solidFill>
-            <a:srgbClr val="0B1220"/>
-          </a:solidFill>
-          <a:ln/>
-        </p:spPr>
-      </p:sp>
-      <p:pic>
-        <p:nvPicPr>
-          <p:cNvPr id="18" name="Image 2" descr="preencoded.png"/>
-          <p:cNvPicPr>
-            <a:picLocks noChangeAspect="1"/>
-          </p:cNvPicPr>
-          <p:nvPr/>
-        </p:nvPicPr>
-        <p:blipFill>
-          <a:blip r:embed="rId5"/>
-          <a:stretch>
-            <a:fillRect/>
-          </a:stretch>
-        </p:blipFill>
-        <p:spPr>
-          <a:xfrm>
-            <a:off x="1042416" y="5367528"/>
-            <a:ext cx="292608" cy="292608"/>
-          </a:xfrm>
-          <a:prstGeom prst="rect">
-            <a:avLst/>
-          </a:prstGeom>
-        </p:spPr>
-      </p:pic>
-      <p:sp>
-        <p:nvSpPr>
-          <p:cNvPr id="19" name="Text 14"/>
-          <p:cNvSpPr/>
-          <p:nvPr/>
-        </p:nvSpPr>
-        <p:spPr>
-          <a:xfrm>
-            <a:off x="1645920" y="5230368"/>
-            <a:ext cx="4041648" cy="347472"/>
-          </a:xfrm>
-          <a:prstGeom prst="rect">
-            <a:avLst/>
-          </a:prstGeom>
-          <a:noFill/>
-          <a:ln/>
-        </p:spPr>
-        <p:txBody>
-          <a:bodyPr wrap="square" rtlCol="0" anchor="ctr"/>
-          <a:lstStyle/>
-          <a:p>
-            <a:pPr marL="0" indent="0">
-              <a:buNone/>
-            </a:pPr>
-            <a:r>
-              <a:rPr lang="en-US" sz="1400" b="1" dirty="0">
-                <a:solidFill>
-                  <a:srgbClr val="141A24"/>
-                </a:solidFill>
-                <a:latin typeface="Arial" pitchFamily="34" charset="0"/>
-                <a:ea typeface="Arial" pitchFamily="34" charset="-122"/>
-                <a:cs typeface="Arial" pitchFamily="34" charset="-120"/>
-              </a:rPr>
-              <a:t>Search Desk</a:t>
-            </a:r>
-            <a:endParaRPr lang="en-US" sz="1400" dirty="0"/>
-          </a:p>
-        </p:txBody>
-      </p:sp>
-      <p:sp>
-        <p:nvSpPr>
-          <p:cNvPr id="20" name="Text 15"/>
-          <p:cNvSpPr/>
-          <p:nvPr/>
-        </p:nvSpPr>
-        <p:spPr>
-          <a:xfrm>
-            <a:off x="1645920" y="5577840"/>
-            <a:ext cx="4041648" cy="411480"/>
-          </a:xfrm>
-          <a:prstGeom prst="rect">
-            <a:avLst/>
-          </a:prstGeom>
-          <a:noFill/>
-          <a:ln/>
-        </p:spPr>
-        <p:txBody>
-          <a:bodyPr wrap="square" rtlCol="0" anchor="t"/>
-          <a:lstStyle/>
-          <a:p>
-            <a:pPr marL="0" indent="0">
-              <a:buNone/>
-            </a:pPr>
-            <a:r>
-              <a:rPr lang="en-US" sz="1050" dirty="0">
-                <a:solidFill>
-                  <a:srgbClr val="141A24"/>
-                </a:solidFill>
-                <a:latin typeface="Arial" pitchFamily="34" charset="0"/>
-                <a:ea typeface="Arial" pitchFamily="34" charset="-122"/>
-                <a:cs typeface="Arial" pitchFamily="34" charset="-120"/>
-              </a:rPr>
-              <a:t>Flat-fee searches for mid-major &amp; D-II/III — paid by the school.</a:t>
-            </a:r>
-            <a:endParaRPr lang="en-US" sz="1050" dirty="0"/>
-          </a:p>
-        </p:txBody>
-      </p:sp>
-      <p:sp>
-        <p:nvSpPr>
-          <p:cNvPr id="21" name="Shape 16"/>
-          <p:cNvSpPr/>
-          <p:nvPr/>
-        </p:nvSpPr>
-        <p:spPr>
-          <a:xfrm>
-            <a:off x="6272784" y="5029200"/>
-            <a:ext cx="5230368" cy="1051560"/>
-          </a:xfrm>
-          <a:prstGeom prst="roundRect">
-            <a:avLst>
-              <a:gd name="adj" fmla="val 8696"/>
-            </a:avLst>
-          </a:prstGeom>
-          <a:solidFill>
-            <a:srgbClr val="F3F1EA"/>
-          </a:solidFill>
-          <a:ln w="12700">
-            <a:solidFill>
-              <a:srgbClr val="E4E7EC"/>
-            </a:solidFill>
-            <a:prstDash val="solid"/>
-          </a:ln>
-        </p:spPr>
-      </p:sp>
-      <p:sp>
-        <p:nvSpPr>
-          <p:cNvPr id="22" name="Shape 17"/>
-          <p:cNvSpPr/>
-          <p:nvPr/>
-        </p:nvSpPr>
-        <p:spPr>
-          <a:xfrm>
-            <a:off x="6501384" y="5239512"/>
-            <a:ext cx="548640" cy="548640"/>
-          </a:xfrm>
-          <a:prstGeom prst="roundRect">
-            <a:avLst>
-              <a:gd name="adj" fmla="val 20000"/>
-            </a:avLst>
-          </a:prstGeom>
-          <a:solidFill>
-            <a:srgbClr val="0B1220"/>
-          </a:solidFill>
-          <a:ln/>
-        </p:spPr>
-      </p:sp>
-      <p:pic>
-        <p:nvPicPr>
-          <p:cNvPr id="23" name="Image 3" descr="preencoded.png"/>
-          <p:cNvPicPr>
-            <a:picLocks noChangeAspect="1"/>
-          </p:cNvPicPr>
-          <p:nvPr/>
-        </p:nvPicPr>
-        <p:blipFill>
-          <a:blip r:embed="rId6"/>
-          <a:stretch>
-            <a:fillRect/>
-          </a:stretch>
-        </p:blipFill>
-        <p:spPr>
-          <a:xfrm>
-            <a:off x="6629400" y="5367528"/>
-            <a:ext cx="292608" cy="292608"/>
-          </a:xfrm>
-          <a:prstGeom prst="rect">
-            <a:avLst/>
-          </a:prstGeom>
-        </p:spPr>
-      </p:pic>
-      <p:sp>
-        <p:nvSpPr>
-          <p:cNvPr id="24" name="Text 18"/>
-          <p:cNvSpPr/>
-          <p:nvPr/>
-        </p:nvSpPr>
-        <p:spPr>
-          <a:xfrm>
-            <a:off x="7232904" y="5230368"/>
-            <a:ext cx="4041648" cy="347472"/>
-          </a:xfrm>
-          <a:prstGeom prst="rect">
-            <a:avLst/>
-          </a:prstGeom>
-          <a:noFill/>
-          <a:ln/>
-        </p:spPr>
-        <p:txBody>
-          <a:bodyPr wrap="square" rtlCol="0" anchor="ctr"/>
-          <a:lstStyle/>
-          <a:p>
-            <a:pPr marL="0" indent="0">
-              <a:buNone/>
-            </a:pPr>
-            <a:r>
-              <a:rPr lang="en-US" sz="1400" b="1" dirty="0">
-                <a:solidFill>
-                  <a:srgbClr val="141A24"/>
-                </a:solidFill>
-                <a:latin typeface="Arial" pitchFamily="34" charset="0"/>
-                <a:ea typeface="Arial" pitchFamily="34" charset="-122"/>
-                <a:cs typeface="Arial" pitchFamily="34" charset="-120"/>
-              </a:rPr>
-              <a:t>NFLPA Agent Rep</a:t>
-            </a:r>
-            <a:endParaRPr lang="en-US" sz="1400" dirty="0"/>
-          </a:p>
-        </p:txBody>
-      </p:sp>
-      <p:sp>
-        <p:nvSpPr>
-          <p:cNvPr id="25" name="Text 19"/>
-          <p:cNvSpPr/>
-          <p:nvPr/>
-        </p:nvSpPr>
-        <p:spPr>
-          <a:xfrm>
-            <a:off x="7232904" y="5577840"/>
-            <a:ext cx="4041648" cy="411480"/>
-          </a:xfrm>
-          <a:prstGeom prst="rect">
-            <a:avLst/>
-          </a:prstGeom>
-          <a:noFill/>
-          <a:ln/>
-        </p:spPr>
-        <p:txBody>
-          <a:bodyPr wrap="square" rtlCol="0" anchor="t"/>
-          <a:lstStyle/>
-          <a:p>
-            <a:pPr marL="0" indent="0">
-              <a:buNone/>
-            </a:pPr>
-            <a:r>
-              <a:rPr lang="en-US" sz="1050" dirty="0">
-                <a:solidFill>
-                  <a:srgbClr val="141A24"/>
-                </a:solidFill>
-                <a:latin typeface="Arial" pitchFamily="34" charset="0"/>
-                <a:ea typeface="Arial" pitchFamily="34" charset="-122"/>
-                <a:cs typeface="Arial" pitchFamily="34" charset="-120"/>
-              </a:rPr>
-              <a:t>Represent NFL players once Kim is certified — 3% of contract.</a:t>
-            </a:r>
-            <a:endParaRPr lang="en-US" sz="1050" dirty="0"/>
-          </a:p>
-        </p:txBody>
-      </p:sp>
-      <p:sp>
-        <p:nvSpPr>
-          <p:cNvPr id="26" name="Text 20"/>
-          <p:cNvSpPr/>
-          <p:nvPr/>
-        </p:nvSpPr>
-        <p:spPr>
-          <a:xfrm>
-            <a:off x="685800" y="6400800"/>
-            <a:ext cx="7315200" cy="274320"/>
-          </a:xfrm>
-          <a:prstGeom prst="rect">
-            <a:avLst/>
-          </a:prstGeom>
-          <a:noFill/>
-          <a:ln/>
-        </p:spPr>
-        <p:txBody>
-          <a:bodyPr wrap="square" rtlCol="0" anchor="ctr"/>
-          <a:lstStyle/>
-          <a:p>
-            <a:pPr marL="0" indent="0">
-              <a:buNone/>
-            </a:pPr>
-            <a:r>
-              <a:rPr lang="en-US" sz="850" b="1" dirty="0">
-                <a:solidFill>
-                  <a:srgbClr val="6B7280"/>
-                </a:solidFill>
-                <a:latin typeface="Arial" pitchFamily="34" charset="0"/>
-                <a:ea typeface="Arial" pitchFamily="34" charset="-122"/>
-                <a:cs typeface="Arial" pitchFamily="34" charset="-120"/>
-              </a:rPr>
-              <a:t>Dexter Sports Co.</a:t>
-            </a:r>
-            <a:r>
-              <a:rPr lang="en-US" sz="850" dirty="0">
-                <a:solidFill>
-                  <a:srgbClr val="AEB4BC"/>
-                </a:solidFill>
-                <a:latin typeface="Arial" pitchFamily="34" charset="0"/>
-                <a:ea typeface="Arial" pitchFamily="34" charset="-122"/>
-                <a:cs typeface="Arial" pitchFamily="34" charset="-120"/>
-              </a:rPr>
-              <a:t>   ·   What We Do</a:t>
-            </a:r>
-            <a:endParaRPr lang="en-US" sz="850" dirty="0"/>
-          </a:p>
-        </p:txBody>
-      </p:sp>
-      <p:sp>
-        <p:nvSpPr>
-          <p:cNvPr id="27" name="Text 21"/>
           <p:cNvSpPr/>
           <p:nvPr/>
         </p:nvSpPr>

</xml_diff>